<commit_message>
Guardar las ediciones manuales de historia_unreal.pptx
Co-Authored-By: Claude Opus 5.5 <noreply@anthropic.com>
</commit_message>
<xml_diff>
--- a/diapositivas/historia_unreal.pptx
+++ b/diapositivas/historia_unreal.pptx
@@ -4,6 +4,9 @@
   <p:sldMasterIdLst>
     <p:sldMasterId id="2147483648" r:id="rId1"/>
   </p:sldMasterIdLst>
+  <p:notesMasterIdLst>
+    <p:notesMasterId r:id="rId15"/>
+  </p:notesMasterIdLst>
   <p:sldIdLst>
     <p:sldId id="256" r:id="rId2"/>
     <p:sldId id="257" r:id="rId3"/>
@@ -19,9 +22,6 @@
     <p:sldId id="267" r:id="rId13"/>
     <p:sldId id="268" r:id="rId14"/>
   </p:sldIdLst>
-  <p:notesMasterIdLst>
-    <p:notesMasterId r:id="rId15"/>
-  </p:notesMasterIdLst>
   <p:sldSz cx="12192000" cy="6858000"/>
   <p:notesSz cx="6858000" cy="12192000"/>
   <p:defaultTextStyle>
@@ -119,7 +119,7 @@
   <p:extLst>
     <p:ext uri="{521415D9-36F7-43E2-AB2F-B90AF26B5E84}">
       <p14:sectionLst xmlns:p14="http://schemas.microsoft.com/office/powerpoint/2010/main">
-        <p14:section name="Historia Unreal" id="{1e639432-f7cb-40e2-e515-19d6d403d2ce}">
+        <p14:section name="Historia Unreal" id="{1E639432-F7CB-40E2-E515-19D6D403D2CE}">
           <p14:sldIdLst>
             <p14:sldId id="256"/>
             <p14:sldId id="257"/>
@@ -167,234 +167,10 @@
           <a:chExt cx="0" cy="0"/>
         </a:xfrm>
       </p:grpSpPr>
-      <p:sp>
-        <p:nvSpPr>
-          <p:cNvPr id="2" name="Header Placeholder 1"/>
-          <p:cNvSpPr>
-            <a:spLocks noGrp="1"/>
-          </p:cNvSpPr>
-          <p:nvPr>
-            <p:ph type="hdr" sz="quarter"/>
-          </p:nvPr>
-        </p:nvSpPr>
-        <p:spPr>
-          <a:xfrm>
-            <a:off x="0" y="0"/>
-            <a:ext cx="2971800" cy="458788"/>
-          </a:xfrm>
-          <a:prstGeom prst="rect">
-            <a:avLst/>
-          </a:prstGeom>
-        </p:spPr>
-        <p:txBody>
-          <a:bodyPr vert="horz" lIns="91440" tIns="45720" rIns="91440" bIns="45720" rtlCol="0"/>
-          <a:lstStyle>
-            <a:lvl1pPr algn="l">
-              <a:defRPr sz="1200"/>
-            </a:lvl1pPr>
-          </a:lstStyle>
-          <a:p>
-            <a:endParaRPr lang="en-US"/>
-          </a:p>
-        </p:txBody>
-      </p:sp>
-      <p:sp>
-        <p:nvSpPr>
-          <p:cNvPr id="3" name="Date Placeholder 2"/>
-          <p:cNvSpPr>
-            <a:spLocks noGrp="1"/>
-          </p:cNvSpPr>
-          <p:nvPr>
-            <p:ph type="dt" idx="1"/>
-          </p:nvPr>
-        </p:nvSpPr>
-        <p:spPr>
-          <a:xfrm>
-            <a:off x="3884613" y="0"/>
-            <a:ext cx="2971800" cy="458788"/>
-          </a:xfrm>
-          <a:prstGeom prst="rect">
-            <a:avLst/>
-          </a:prstGeom>
-        </p:spPr>
-        <p:txBody>
-          <a:bodyPr vert="horz" lIns="91440" tIns="45720" rIns="91440" bIns="45720" rtlCol="0"/>
-          <a:lstStyle>
-            <a:lvl1pPr algn="r">
-              <a:defRPr sz="1200"/>
-            </a:lvl1pPr>
-          </a:lstStyle>
-          <a:p>
-            <a:fld id="{5282F153-3F37-0F45-9E97-73ACFA13230C}" type="datetimeFigureOut">
-              <a:rPr lang="en-US"/>
-              <a:t>7/23/19</a:t>
-            </a:fld>
-            <a:endParaRPr lang="en-US"/>
-          </a:p>
-        </p:txBody>
-      </p:sp>
-      <p:sp>
-        <p:nvSpPr>
-          <p:cNvPr id="4" name="Slide Image Placeholder 3"/>
-          <p:cNvSpPr>
-            <a:spLocks noGrp="1" noRot="1" noChangeAspect="1"/>
-          </p:cNvSpPr>
-          <p:nvPr>
-            <p:ph type="sldImg" idx="2"/>
-          </p:nvPr>
-        </p:nvSpPr>
-        <p:spPr>
-          <a:xfrm>
-            <a:off x="685800" y="1143000"/>
-            <a:ext cx="5486400" cy="3086100"/>
-          </a:xfrm>
-          <a:prstGeom prst="rect">
-            <a:avLst/>
-          </a:prstGeom>
-          <a:noFill/>
-          <a:ln w="12700">
-            <a:solidFill>
-              <a:prstClr val="black"/>
-            </a:solidFill>
-          </a:ln>
-        </p:spPr>
-        <p:txBody>
-          <a:bodyPr vert="horz" lIns="91440" tIns="45720" rIns="91440" bIns="45720" rtlCol="0" anchor="ctr"/>
-          <a:lstStyle/>
-          <a:p>
-            <a:endParaRPr lang="en-US"/>
-          </a:p>
-        </p:txBody>
-      </p:sp>
-      <p:sp>
-        <p:nvSpPr>
-          <p:cNvPr id="5" name="Notes Placeholder 4"/>
-          <p:cNvSpPr>
-            <a:spLocks noGrp="1"/>
-          </p:cNvSpPr>
-          <p:nvPr>
-            <p:ph type="body" sz="quarter" idx="3"/>
-          </p:nvPr>
-        </p:nvSpPr>
-        <p:spPr>
-          <a:xfrm>
-            <a:off x="685800" y="4400550"/>
-            <a:ext cx="5486400" cy="3600450"/>
-          </a:xfrm>
-          <a:prstGeom prst="rect">
-            <a:avLst/>
-          </a:prstGeom>
-        </p:spPr>
-        <p:txBody>
-          <a:bodyPr vert="horz" lIns="91440" tIns="45720" rIns="91440" bIns="45720" rtlCol="0"/>
-          <a:lstStyle/>
-          <a:p>
-            <a:pPr lvl="0"/>
-            <a:r>
-              <a:rPr lang="en-US"/>
-              <a:t>Click to edit Master text styles</a:t>
-            </a:r>
-          </a:p>
-          <a:p>
-            <a:pPr lvl="1"/>
-            <a:r>
-              <a:rPr lang="en-US"/>
-              <a:t>Second level</a:t>
-            </a:r>
-          </a:p>
-          <a:p>
-            <a:pPr lvl="2"/>
-            <a:r>
-              <a:rPr lang="en-US"/>
-              <a:t>Third level</a:t>
-            </a:r>
-          </a:p>
-          <a:p>
-            <a:pPr lvl="3"/>
-            <a:r>
-              <a:rPr lang="en-US"/>
-              <a:t>Fourth level</a:t>
-            </a:r>
-          </a:p>
-          <a:p>
-            <a:pPr lvl="4"/>
-            <a:r>
-              <a:rPr lang="en-US"/>
-              <a:t>Fifth level</a:t>
-            </a:r>
-          </a:p>
-        </p:txBody>
-      </p:sp>
-      <p:sp>
-        <p:nvSpPr>
-          <p:cNvPr id="6" name="Footer Placeholder 5"/>
-          <p:cNvSpPr>
-            <a:spLocks noGrp="1"/>
-          </p:cNvSpPr>
-          <p:nvPr>
-            <p:ph type="ftr" sz="quarter" idx="4"/>
-          </p:nvPr>
-        </p:nvSpPr>
-        <p:spPr>
-          <a:xfrm>
-            <a:off x="0" y="8685213"/>
-            <a:ext cx="2971800" cy="458787"/>
-          </a:xfrm>
-          <a:prstGeom prst="rect">
-            <a:avLst/>
-          </a:prstGeom>
-        </p:spPr>
-        <p:txBody>
-          <a:bodyPr vert="horz" lIns="91440" tIns="45720" rIns="91440" bIns="45720" rtlCol="0" anchor="b"/>
-          <a:lstStyle>
-            <a:lvl1pPr algn="l">
-              <a:defRPr sz="1200"/>
-            </a:lvl1pPr>
-          </a:lstStyle>
-          <a:p>
-            <a:endParaRPr lang="en-US"/>
-          </a:p>
-        </p:txBody>
-      </p:sp>
-      <p:sp>
-        <p:nvSpPr>
-          <p:cNvPr id="7" name="Slide Number Placeholder 6"/>
-          <p:cNvSpPr>
-            <a:spLocks noGrp="1"/>
-          </p:cNvSpPr>
-          <p:nvPr>
-            <p:ph type="sldNum" sz="quarter" idx="5"/>
-          </p:nvPr>
-        </p:nvSpPr>
-        <p:spPr>
-          <a:xfrm>
-            <a:off x="3884613" y="8685213"/>
-            <a:ext cx="2971800" cy="458787"/>
-          </a:xfrm>
-          <a:prstGeom prst="rect">
-            <a:avLst/>
-          </a:prstGeom>
-        </p:spPr>
-        <p:txBody>
-          <a:bodyPr vert="horz" lIns="91440" tIns="45720" rIns="91440" bIns="45720" rtlCol="0" anchor="b"/>
-          <a:lstStyle>
-            <a:lvl1pPr algn="r">
-              <a:defRPr sz="1200"/>
-            </a:lvl1pPr>
-          </a:lstStyle>
-          <a:p>
-            <a:fld id="{CE5E9CC1-C706-0F49-92D6-E571CC5EEA8F}" type="slidenum">
-              <a:rPr lang="en-US"/>
-              <a:t>‹#›</a:t>
-            </a:fld>
-            <a:endParaRPr lang="en-US"/>
-          </a:p>
-        </p:txBody>
-      </p:sp>
     </p:spTree>
     <p:extLst>
       <p:ext uri="{BB962C8B-B14F-4D97-AF65-F5344CB8AC3E}">
-        <p14:creationId xmlns:p14="http://schemas.microsoft.com/office/powerpoint/2010/main" val="1024086991"/>
+        <p14:creationId xmlns:p14="http://schemas.microsoft.com/office/powerpoint/2010/main" val="4266474977"/>
       </p:ext>
     </p:extLst>
   </p:cSld>
@@ -542,7 +318,6 @@
               <a:rPr lang="en-US" dirty="0"/>
               <a:t>Historia de apoyo para la regla del curso «primero las personas, después la IA» (bloque 1, minutos 15–20). Duración orientativa: 8–10 minutos. Si no hay tiempo, usar solo la diapositiva resumen del bloque 1.</a:t>
             </a:r>
-            <a:endParaRPr lang="en-US" dirty="0"/>
           </a:p>
         </p:txBody>
       </p:sp>
@@ -630,7 +405,6 @@
               <a:rPr lang="en-US" dirty="0"/>
               <a:t>Los autores lo llaman un dilema social: a cada uno le conviene usar la IA, pero si todos la usamos igual, el conjunto se empobrece.</a:t>
             </a:r>
-            <a:endParaRPr lang="en-US" dirty="0"/>
           </a:p>
         </p:txBody>
       </p:sp>
@@ -718,7 +492,6 @@
               <a:rPr lang="en-US" dirty="0"/>
               <a:t>Recorrer la tabla fila a fila. Conectar con la búsqueda de empleo: si todo el mundo escribe su carta de presentación con la misma IA y el mismo prompt, todas suenan igual. Lo que diferencia es lo que pone cada persona.</a:t>
             </a:r>
-            <a:endParaRPr lang="en-US" dirty="0"/>
           </a:p>
         </p:txBody>
       </p:sp>
@@ -806,7 +579,6 @@
               <a:rPr lang="en-US" dirty="0"/>
               <a:t>Enlazar con la regla del curso y con el Ejercicio 1: lo comprobaremos comparando las ideas del grupo con las de la IA. No adelantar quién gana: lo dirán los datos del propio grupo.</a:t>
             </a:r>
-            <a:endParaRPr lang="en-US" dirty="0"/>
           </a:p>
         </p:txBody>
       </p:sp>
@@ -894,7 +666,6 @@
               <a:rPr lang="en-US" dirty="0"/>
               <a:t>Las opiniones de foros (ResetEra, Steam) reflejan la percepción de jugadores, no un estudio. El estudio de Science Advances sí es una investigación revisada por pares.</a:t>
             </a:r>
-            <a:endParaRPr lang="en-US" dirty="0"/>
           </a:p>
         </p:txBody>
       </p:sp>
@@ -982,7 +753,6 @@
               <a:rPr lang="en-US" dirty="0"/>
               <a:t>Lanzar la pregunta y dejarla abierta. Se responde al final de la historia.</a:t>
             </a:r>
-            <a:endParaRPr lang="en-US" dirty="0"/>
           </a:p>
         </p:txBody>
       </p:sp>
@@ -1072,7 +842,6 @@
 Lumen: iluminación global y reflejos que se actualizan en tiempo real. Nanite: geometría virtualizada que permite usar modelos de altísimo detalle, como escaneos fotogramétricos. Megascans: la mayor biblioteca de fotogrametría del mundo en 2019, de Quixel, empresa que compró Epic Games; durante años fue gratuita para quien usaba Unreal (desde 2025 parte es de pago, en la tienda Fab).
 Fechas según Wikipedia (artículo «Unreal Engine 5»).</a:t>
             </a:r>
-            <a:endParaRPr lang="en-US" dirty="0"/>
           </a:p>
         </p:txBody>
       </p:sp>
@@ -1161,7 +930,6 @@
               <a:t>La cita es de Tom Guillermin, director técnico de Sandfall Interactive, recogida por Creative Bloq: con Lumen y Nanite, un equipo de unas 30 personas alcanzó un nivel gráfico comparable al de estudios con cientos de desarrolladores.
 Para la captura (el repositorio del curso es público, por eso no se incluyen imágenes con derechos de autor): buscar «The Matrix Awakens Unreal Engine 5» en el canal oficial de Unreal Engine en YouTube o en unrealengine.com, y pegar una captura en el hueco.</a:t>
             </a:r>
-            <a:endParaRPr lang="en-US" dirty="0"/>
           </a:p>
         </p:txBody>
       </p:sp>
@@ -1251,7 +1019,6 @@
 Ser honestos: es una percepción de parte de la comunidad, no un hecho medido. En el mismo hilo hay quien responde que no todos los juegos de Unreal Engine 5 se parecen. El debate es justamente lo interesante: ¿la culpa es de la herramienta o de cómo se usa?
 Opcional: pegar encima de las miniaturas capturas de dos o tres juegos de Unreal Engine 5 con paisajes realistas, para que el grupo juzgue si se parecen.</a:t>
             </a:r>
-            <a:endParaRPr lang="en-US" dirty="0"/>
           </a:p>
         </p:txBody>
       </p:sp>
@@ -1340,7 +1107,6 @@
               <a:t>Las tres causas son las que más se repiten en los foros: los ajustes por defecto (iluminación automática, el mismo mapeo de tonos «cinematográfico»), los recursos compartidos (bibliotecas como Megascans) y la comodidad.
 La frase de abajo es la clave de toda la historia: la herramienta no tiene la culpa. Decide quien la usa… o quien deja de decidir.</a:t>
             </a:r>
-            <a:endParaRPr lang="en-US" dirty="0"/>
           </a:p>
         </p:txBody>
       </p:sp>
@@ -1431,7 +1197,6 @@
 El propio director técnico avisó de que usar Unreal Engine 5 «puede ser una trampa» (titular de Creative Bloq): la gente espera calidad de gran estudio en todo. La herramienta da el acabado; lo que hace único al juego lo pone el equipo.
 Para la captura: kit de prensa oficial de Sandfall Interactive o la página del juego en Steam o PlayStation Store.</a:t>
             </a:r>
-            <a:endParaRPr lang="en-US" dirty="0"/>
           </a:p>
         </p:txBody>
       </p:sp>
@@ -1519,7 +1284,6 @@
               <a:rPr lang="en-US" dirty="0"/>
               <a:t>Pregunta puente. Dejar que alguien del grupo intente responderla antes de pasar.</a:t>
             </a:r>
-            <a:endParaRPr lang="en-US" dirty="0"/>
           </a:p>
         </p:txBody>
       </p:sp>
@@ -1609,7 +1373,6 @@
 Cifras exactas: con cinco ideas de la IA, los relatos fueron un 8,1 % más novedosos y un 9,0 % más útiles que los escritos sin ayuda. Las mejoras fueron mayores en las personas menos creativas (hasta +10,7 % en novedad y +11,5 % en utilidad). Pero los relatos hechos con ayuda de la IA se parecían más entre sí: un 10,7 % del rango de similitud con una idea de la IA (8,9 % con cinco).
 Ojo: la IA no lo hizo peor. Ayudó a cada persona. El problema aparece al mirar el conjunto.</a:t>
             </a:r>
-            <a:endParaRPr lang="en-US" dirty="0"/>
           </a:p>
         </p:txBody>
       </p:sp>
@@ -1687,6 +1450,7 @@
         <a:solidFill>
           <a:schemeClr val="tx1"/>
         </a:solidFill>
+        <a:effectLst/>
       </p:bgPr>
     </p:bg>
     <p:spTree>
@@ -1706,9 +1470,11 @@
       <p:sp>
         <p:nvSpPr>
           <p:cNvPr id="2" name="Text 0"/>
-          <p:cNvSpPr/>
+          <p:cNvSpPr>
+            <a:spLocks noGrp="1"/>
+          </p:cNvSpPr>
           <p:nvPr>
-            <p:ph idx="100" type="title" hasCustomPrompt="1"/>
+            <p:ph type="title" idx="100" hasCustomPrompt="1"/>
           </p:nvPr>
         </p:nvSpPr>
         <p:spPr>
@@ -1725,7 +1491,7 @@
         <p:txBody>
           <a:bodyPr wrap="square" rtlCol="0"/>
           <a:lstStyle>
-            <a:lvl1pPr algn="l" indent="0" marL="0">
+            <a:lvl1pPr marL="0" indent="0" algn="l">
               <a:buNone/>
               <a:defRPr lang="en-US" sz="4400" b="1" dirty="0">
                 <a:solidFill>
@@ -1735,7 +1501,7 @@
             </a:lvl1pPr>
           </a:lstStyle>
           <a:p>
-            <a:pPr algn="l" indent="0" marL="0">
+            <a:pPr marL="0" indent="0" algn="l">
               <a:buNone/>
             </a:pPr>
             <a:endParaRPr lang="en-US" sz="4400" dirty="0"/>
@@ -1745,9 +1511,11 @@
       <p:sp>
         <p:nvSpPr>
           <p:cNvPr id="3" name="Text 0"/>
-          <p:cNvSpPr/>
+          <p:cNvSpPr>
+            <a:spLocks noGrp="1"/>
+          </p:cNvSpPr>
           <p:nvPr>
-            <p:ph idx="101" type="body" hasCustomPrompt="1"/>
+            <p:ph type="body" idx="101" hasCustomPrompt="1"/>
           </p:nvPr>
         </p:nvSpPr>
         <p:spPr>
@@ -1764,7 +1532,7 @@
         <p:txBody>
           <a:bodyPr wrap="square" rtlCol="0"/>
           <a:lstStyle>
-            <a:lvl1pPr indent="0" marL="0">
+            <a:lvl1pPr marL="0" indent="0">
               <a:buNone/>
               <a:defRPr lang="en-US" sz="2000" dirty="0">
                 <a:solidFill>
@@ -1774,7 +1542,7 @@
             </a:lvl1pPr>
           </a:lstStyle>
           <a:p>
-            <a:pPr indent="0" marL="0">
+            <a:pPr marL="0" indent="0">
               <a:buNone/>
             </a:pPr>
             <a:endParaRPr lang="en-US" sz="2000" dirty="0"/>
@@ -1797,6 +1565,7 @@
         <a:solidFill>
           <a:schemeClr val="tx1"/>
         </a:solidFill>
+        <a:effectLst/>
       </p:bgPr>
     </p:bg>
     <p:spTree>
@@ -1816,9 +1585,11 @@
       <p:sp>
         <p:nvSpPr>
           <p:cNvPr id="2" name="Text 0"/>
-          <p:cNvSpPr/>
+          <p:cNvSpPr>
+            <a:spLocks noGrp="1"/>
+          </p:cNvSpPr>
           <p:nvPr>
-            <p:ph idx="100" type="title" hasCustomPrompt="1"/>
+            <p:ph type="title" idx="100" hasCustomPrompt="1"/>
           </p:nvPr>
         </p:nvSpPr>
         <p:spPr>
@@ -1835,7 +1606,7 @@
         <p:txBody>
           <a:bodyPr wrap="square" rtlCol="0"/>
           <a:lstStyle>
-            <a:lvl1pPr algn="l" indent="0" marL="0">
+            <a:lvl1pPr marL="0" indent="0" algn="l">
               <a:buNone/>
               <a:defRPr lang="en-US" sz="4000" b="1" dirty="0">
                 <a:solidFill>
@@ -1845,7 +1616,7 @@
             </a:lvl1pPr>
           </a:lstStyle>
           <a:p>
-            <a:pPr algn="l" indent="0" marL="0">
+            <a:pPr marL="0" indent="0" algn="l">
               <a:buNone/>
             </a:pPr>
             <a:endParaRPr lang="en-US" sz="4000" dirty="0"/>
@@ -1855,9 +1626,11 @@
       <p:sp>
         <p:nvSpPr>
           <p:cNvPr id="3" name="Text 0"/>
-          <p:cNvSpPr/>
+          <p:cNvSpPr>
+            <a:spLocks noGrp="1"/>
+          </p:cNvSpPr>
           <p:nvPr>
-            <p:ph idx="101" type="body" hasCustomPrompt="1"/>
+            <p:ph type="body" idx="101" hasCustomPrompt="1"/>
           </p:nvPr>
         </p:nvSpPr>
         <p:spPr>
@@ -1874,7 +1647,7 @@
         <p:txBody>
           <a:bodyPr wrap="square" rtlCol="0"/>
           <a:lstStyle>
-            <a:lvl1pPr indent="0" marL="0">
+            <a:lvl1pPr marL="0" indent="0">
               <a:buNone/>
               <a:defRPr lang="en-US" sz="2200" dirty="0">
                 <a:solidFill>
@@ -1884,7 +1657,7 @@
             </a:lvl1pPr>
           </a:lstStyle>
           <a:p>
-            <a:pPr indent="0" marL="0">
+            <a:pPr marL="0" indent="0">
               <a:buNone/>
             </a:pPr>
             <a:endParaRPr lang="en-US" sz="2200" dirty="0"/>
@@ -1907,6 +1680,7 @@
         <a:solidFill>
           <a:schemeClr val="bg1"/>
         </a:solidFill>
+        <a:effectLst/>
       </p:bgPr>
     </p:bg>
     <p:spTree>
@@ -1926,9 +1700,11 @@
       <p:sp>
         <p:nvSpPr>
           <p:cNvPr id="2" name="Text 0"/>
-          <p:cNvSpPr/>
+          <p:cNvSpPr>
+            <a:spLocks noGrp="1"/>
+          </p:cNvSpPr>
           <p:nvPr>
-            <p:ph idx="100" type="title" hasCustomPrompt="1"/>
+            <p:ph type="title" idx="100" hasCustomPrompt="1"/>
           </p:nvPr>
         </p:nvSpPr>
         <p:spPr>
@@ -1945,7 +1721,7 @@
         <p:txBody>
           <a:bodyPr wrap="square" rtlCol="0"/>
           <a:lstStyle>
-            <a:lvl1pPr algn="l" indent="0" marL="0">
+            <a:lvl1pPr marL="0" indent="0" algn="l">
               <a:buNone/>
               <a:defRPr lang="en-US" sz="3200" b="1" dirty="0">
                 <a:solidFill>
@@ -1955,7 +1731,7 @@
             </a:lvl1pPr>
           </a:lstStyle>
           <a:p>
-            <a:pPr algn="l" indent="0" marL="0">
+            <a:pPr marL="0" indent="0" algn="l">
               <a:buNone/>
             </a:pPr>
             <a:endParaRPr lang="en-US" sz="3200" dirty="0"/>
@@ -1983,7 +1759,7 @@
           <a:bodyPr wrap="square" lIns="0" tIns="0" rIns="0" bIns="0" rtlCol="0" anchor="ctr"/>
           <a:lstStyle/>
           <a:p>
-            <a:pPr indent="0" marL="0">
+            <a:pPr marL="0" indent="0">
               <a:buNone/>
             </a:pPr>
             <a:r>
@@ -2018,7 +1794,7 @@
           </a:prstGeom>
           <a:extLst>
             <a:ext uri="{C572A759-6A51-4108-AA02-DFA0A04FC94B}">
-              <ma14:wrappingTextBoxFlag xmlns:ma14="http://schemas.microsoft.com/office/mac/drawingml/2011/main" val="0"/>
+              <ma14:wrappingTextBoxFlag xmlns:ma14="http://schemas.microsoft.com/office/mac/drawingml/2011/main" xmlns="" val="0"/>
             </a:ext>
           </a:extLst>
         </p:spPr>
@@ -2036,8 +1812,8 @@
           <a:p>
             <a:pPr algn="r"/>
             <a:fld id="{F7021451-1387-4CA6-816F-3879F97B5CBC}" type="slidenum">
-              <a:rPr b="0" lang="en-US"/>
-              <a:t>1004</a:t>
+              <a:rPr lang="en-US" b="0"/>
+              <a:t>‹Nº›</a:t>
             </a:fld>
             <a:endParaRPr lang="en-US"/>
           </a:p>
@@ -2059,6 +1835,7 @@
         <a:solidFill>
           <a:schemeClr val="tx1"/>
         </a:solidFill>
+        <a:effectLst/>
       </p:bgPr>
     </p:bg>
     <p:spTree>
@@ -2078,9 +1855,11 @@
       <p:sp>
         <p:nvSpPr>
           <p:cNvPr id="2" name="Text 0"/>
-          <p:cNvSpPr/>
+          <p:cNvSpPr>
+            <a:spLocks noGrp="1"/>
+          </p:cNvSpPr>
           <p:nvPr>
-            <p:ph idx="100" type="body" hasCustomPrompt="1"/>
+            <p:ph type="body" idx="100" hasCustomPrompt="1"/>
           </p:nvPr>
         </p:nvSpPr>
         <p:spPr>
@@ -2097,7 +1876,7 @@
         <p:txBody>
           <a:bodyPr wrap="square" rtlCol="0"/>
           <a:lstStyle>
-            <a:lvl1pPr indent="0" marL="0">
+            <a:lvl1pPr marL="0" indent="0">
               <a:buNone/>
               <a:defRPr lang="en-US" sz="3400" dirty="0">
                 <a:solidFill>
@@ -2107,7 +1886,7 @@
             </a:lvl1pPr>
           </a:lstStyle>
           <a:p>
-            <a:pPr indent="0" marL="0">
+            <a:pPr marL="0" indent="0">
               <a:buNone/>
             </a:pPr>
             <a:endParaRPr lang="en-US" sz="3400" dirty="0"/>
@@ -2135,7 +1914,7 @@
           <a:bodyPr wrap="square" lIns="0" tIns="0" rIns="0" bIns="0" rtlCol="0" anchor="ctr"/>
           <a:lstStyle/>
           <a:p>
-            <a:pPr indent="0" marL="0">
+            <a:pPr marL="0" indent="0">
               <a:buNone/>
             </a:pPr>
             <a:r>
@@ -2170,7 +1949,7 @@
           </a:prstGeom>
           <a:extLst>
             <a:ext uri="{C572A759-6A51-4108-AA02-DFA0A04FC94B}">
-              <ma14:wrappingTextBoxFlag xmlns:ma14="http://schemas.microsoft.com/office/mac/drawingml/2011/main" val="0"/>
+              <ma14:wrappingTextBoxFlag xmlns:ma14="http://schemas.microsoft.com/office/mac/drawingml/2011/main" xmlns="" val="0"/>
             </a:ext>
           </a:extLst>
         </p:spPr>
@@ -2188,8 +1967,8 @@
           <a:p>
             <a:pPr algn="r"/>
             <a:fld id="{F7021451-1387-4CA6-816F-3879F97B5CBC}" type="slidenum">
-              <a:rPr b="0" lang="en-US"/>
-              <a:t>1005</a:t>
+              <a:rPr lang="en-US" b="0"/>
+              <a:t>‹Nº›</a:t>
             </a:fld>
             <a:endParaRPr lang="en-US"/>
           </a:p>
@@ -2206,6 +1985,11 @@
 <file path=ppt/slideMasters/slideMaster1.xml><?xml version="1.0" encoding="utf-8"?>
 <p:sldMaster xmlns:a="http://schemas.openxmlformats.org/drawingml/2006/main" xmlns:r="http://schemas.openxmlformats.org/officeDocument/2006/relationships" xmlns:p="http://schemas.openxmlformats.org/presentationml/2006/main">
   <p:cSld>
+    <p:bg>
+      <p:bgRef idx="1001">
+        <a:schemeClr val="bg1"/>
+      </p:bgRef>
+    </p:bg>
     <p:spTree>
       <p:nvGrpSpPr>
         <p:cNvPr id="1" name=""/>
@@ -2240,7 +2024,7 @@
           </a:prstGeom>
           <a:extLst>
             <a:ext uri="{C572A759-6A51-4108-AA02-DFA0A04FC94B}">
-              <ma14:wrappingTextBoxFlag xmlns:ma14="http://schemas.microsoft.com/office/mac/drawingml/2011/main" val="0"/>
+              <ma14:wrappingTextBoxFlag xmlns:ma14="http://schemas.microsoft.com/office/mac/drawingml/2011/main" xmlns="" val="0"/>
             </a:ext>
           </a:extLst>
         </p:spPr>
@@ -2258,8 +2042,8 @@
           <a:p>
             <a:pPr algn="r"/>
             <a:fld id="{F7021451-1387-4CA6-816F-3879F97B5CBC}" type="slidenum">
-              <a:rPr b="0" lang="en-US"/>
-              <a:t>null</a:t>
+              <a:rPr lang="en-US" b="0"/>
+              <a:t>‹Nº›</a:t>
             </a:fld>
             <a:endParaRPr lang="en-US"/>
           </a:p>
@@ -2549,9 +2333,11 @@
       <p:sp>
         <p:nvSpPr>
           <p:cNvPr id="2" name="Text 0"/>
-          <p:cNvSpPr/>
+          <p:cNvSpPr>
+            <a:spLocks noGrp="1"/>
+          </p:cNvSpPr>
           <p:nvPr>
-            <p:ph idx="100" type="title" hasCustomPrompt="1"/>
+            <p:ph type="title" idx="100" hasCustomPrompt="1"/>
           </p:nvPr>
         </p:nvSpPr>
         <p:spPr>
@@ -2569,7 +2355,7 @@
           <a:bodyPr wrap="square" lIns="0" tIns="0" rIns="0" bIns="0" rtlCol="0" anchor="b"/>
           <a:lstStyle/>
           <a:p>
-            <a:pPr algn="l" indent="0" marL="0">
+            <a:pPr marL="0" indent="0" algn="l">
               <a:buNone/>
             </a:pPr>
             <a:r>
@@ -2587,9 +2373,11 @@
       <p:sp>
         <p:nvSpPr>
           <p:cNvPr id="3" name="Text 0"/>
-          <p:cNvSpPr/>
+          <p:cNvSpPr>
+            <a:spLocks noGrp="1"/>
+          </p:cNvSpPr>
           <p:nvPr>
-            <p:ph idx="101" type="body" hasCustomPrompt="1"/>
+            <p:ph type="body" idx="101" hasCustomPrompt="1"/>
           </p:nvPr>
         </p:nvSpPr>
         <p:spPr>
@@ -2607,7 +2395,7 @@
           <a:bodyPr wrap="square" lIns="0" tIns="0" rIns="0" bIns="0" rtlCol="0" anchor="t"/>
           <a:lstStyle/>
           <a:p>
-            <a:pPr indent="0" marL="0">
+            <a:pPr marL="0" indent="0">
               <a:buNone/>
             </a:pPr>
             <a:r>
@@ -2644,14 +2432,14 @@
       </p:sp>
       <p:pic>
         <p:nvPicPr>
-          <p:cNvPr id="5" name="Image 0" descr="Mando">    </p:cNvPr>
+          <p:cNvPr id="5" name="Image 0" descr="Mando"/>
           <p:cNvPicPr>
             <a:picLocks noChangeAspect="1"/>
           </p:cNvPicPr>
           <p:nvPr/>
         </p:nvPicPr>
         <p:blipFill>
-          <a:blip r:embed="rId1"/>
+          <a:blip r:embed="rId3"/>
           <a:stretch>
             <a:fillRect/>
           </a:stretch>
@@ -2694,9 +2482,11 @@
       <p:sp>
         <p:nvSpPr>
           <p:cNvPr id="2" name="Text 0"/>
-          <p:cNvSpPr/>
+          <p:cNvSpPr>
+            <a:spLocks noGrp="1"/>
+          </p:cNvSpPr>
           <p:nvPr>
-            <p:ph idx="100" type="title" hasCustomPrompt="1"/>
+            <p:ph type="title" idx="100" hasCustomPrompt="1"/>
           </p:nvPr>
         </p:nvSpPr>
         <p:spPr>
@@ -2714,7 +2504,7 @@
           <a:bodyPr wrap="square" lIns="0" tIns="0" rIns="0" bIns="0" rtlCol="0" anchor="ctr"/>
           <a:lstStyle/>
           <a:p>
-            <a:pPr algn="l" indent="0" marL="0">
+            <a:pPr marL="0" indent="0" algn="l">
               <a:buNone/>
             </a:pPr>
             <a:r>
@@ -2773,14 +2563,14 @@
       </p:sp>
       <p:pic>
         <p:nvPicPr>
-          <p:cNvPr id="5" name="Image 0" descr="Cada persona">    </p:cNvPr>
+          <p:cNvPr id="5" name="Image 0" descr="Cada persona"/>
           <p:cNvPicPr>
             <a:picLocks noChangeAspect="1"/>
           </p:cNvPicPr>
           <p:nvPr/>
         </p:nvPicPr>
         <p:blipFill>
-          <a:blip r:embed="rId1"/>
+          <a:blip r:embed="rId3"/>
           <a:stretch>
             <a:fillRect/>
           </a:stretch>
@@ -2816,7 +2606,7 @@
           <a:bodyPr wrap="square" lIns="0" tIns="0" rIns="0" bIns="0" rtlCol="0" anchor="ctr"/>
           <a:lstStyle/>
           <a:p>
-            <a:pPr indent="0" marL="0">
+            <a:pPr marL="0" indent="0">
               <a:buNone/>
             </a:pPr>
             <a:r>
@@ -2830,7 +2620,7 @@
             <a:endParaRPr lang="en-US" sz="2000" dirty="0"/>
           </a:p>
           <a:p>
-            <a:pPr indent="0" marL="0">
+            <a:pPr marL="0" indent="0">
               <a:buNone/>
             </a:pPr>
             <a:r>
@@ -2889,14 +2679,14 @@
       </p:sp>
       <p:pic>
         <p:nvPicPr>
-          <p:cNvPr id="9" name="Image 1" descr="El conjunto">    </p:cNvPr>
+          <p:cNvPr id="9" name="Image 1" descr="El conjunto"/>
           <p:cNvPicPr>
             <a:picLocks noChangeAspect="1"/>
           </p:cNvPicPr>
           <p:nvPr/>
         </p:nvPicPr>
         <p:blipFill>
-          <a:blip r:embed="rId2"/>
+          <a:blip r:embed="rId4"/>
           <a:stretch>
             <a:fillRect/>
           </a:stretch>
@@ -2932,7 +2722,7 @@
           <a:bodyPr wrap="square" lIns="0" tIns="0" rIns="0" bIns="0" rtlCol="0" anchor="ctr"/>
           <a:lstStyle/>
           <a:p>
-            <a:pPr indent="0" marL="0">
+            <a:pPr marL="0" indent="0">
               <a:buNone/>
             </a:pPr>
             <a:r>
@@ -2946,7 +2736,7 @@
             <a:endParaRPr lang="en-US" sz="2000" dirty="0"/>
           </a:p>
           <a:p>
-            <a:pPr indent="0" marL="0">
+            <a:pPr marL="0" indent="0">
               <a:buNone/>
             </a:pPr>
             <a:r>
@@ -3004,7 +2794,7 @@
           <a:bodyPr wrap="square" lIns="0" tIns="0" rIns="0" bIns="0" rtlCol="0" anchor="ctr"/>
           <a:lstStyle/>
           <a:p>
-            <a:pPr indent="0" marL="0">
+            <a:pPr marL="0" indent="0">
               <a:spcAft>
                 <a:spcPts val="600"/>
               </a:spcAft>
@@ -3021,7 +2811,7 @@
             <a:endParaRPr lang="en-US" sz="1900" dirty="0"/>
           </a:p>
           <a:p>
-            <a:pPr indent="0" marL="0">
+            <a:pPr marL="0" indent="0">
               <a:spcAft>
                 <a:spcPts val="600"/>
               </a:spcAft>
@@ -3060,7 +2850,7 @@
           <a:bodyPr wrap="square" lIns="0" tIns="0" rIns="0" bIns="0" rtlCol="0" anchor="ctr"/>
           <a:lstStyle/>
           <a:p>
-            <a:pPr indent="0" marL="0">
+            <a:pPr marL="0" indent="0">
               <a:buNone/>
             </a:pPr>
             <a:r>
@@ -3095,7 +2885,7 @@
           </a:prstGeom>
           <a:extLst>
             <a:ext uri="{C572A759-6A51-4108-AA02-DFA0A04FC94B}">
-              <ma14:wrappingTextBoxFlag xmlns:ma14="http://schemas.microsoft.com/office/mac/drawingml/2011/main" val="0"/>
+              <ma14:wrappingTextBoxFlag xmlns:ma14="http://schemas.microsoft.com/office/mac/drawingml/2011/main" xmlns="" val="0"/>
             </a:ext>
           </a:extLst>
         </p:spPr>
@@ -3113,7 +2903,7 @@
           <a:p>
             <a:pPr algn="r"/>
             <a:fld id="{F7021451-1387-4CA6-816F-3879F97B5CBC}" type="slidenum">
-              <a:rPr b="0" lang="en-US"/>
+              <a:rPr lang="en-US" b="0"/>
               <a:t>10</a:t>
             </a:fld>
             <a:endParaRPr lang="en-US"/>
@@ -3148,9 +2938,11 @@
       <p:sp>
         <p:nvSpPr>
           <p:cNvPr id="2" name="Text 0"/>
-          <p:cNvSpPr/>
+          <p:cNvSpPr>
+            <a:spLocks noGrp="1"/>
+          </p:cNvSpPr>
           <p:nvPr>
-            <p:ph idx="100" type="title" hasCustomPrompt="1"/>
+            <p:ph type="title" idx="100" hasCustomPrompt="1"/>
           </p:nvPr>
         </p:nvSpPr>
         <p:spPr>
@@ -3168,7 +2960,7 @@
           <a:bodyPr wrap="square" lIns="0" tIns="0" rIns="0" bIns="0" rtlCol="0" anchor="ctr"/>
           <a:lstStyle/>
           <a:p>
-            <a:pPr algn="l" indent="0" marL="0">
+            <a:pPr marL="0" indent="0" algn="l">
               <a:buNone/>
             </a:pPr>
             <a:r>
@@ -3199,16 +2991,34 @@
         </p:nvGraphicFramePr>
         <p:xfrm>
           <a:off x="548640" y="1463040"/>
-          <a:ext cx="11094415" cy="914400"/>
+          <a:ext cx="11091672" cy="3794760"/>
         </p:xfrm>
         <a:graphic>
           <a:graphicData uri="http://schemas.openxmlformats.org/drawingml/2006/table">
             <a:tbl>
               <a:tblPr/>
               <a:tblGrid>
-                <a:gridCol w="2194560"/>
-                <a:gridCol w="4448556"/>
-                <a:gridCol w="4448556"/>
+                <a:gridCol w="2194560">
+                  <a:extLst>
+                    <a:ext uri="{9D8B030D-6E8A-4147-A177-3AD203B41FA5}">
+                      <a16:colId xmlns:a16="http://schemas.microsoft.com/office/drawing/2014/main" val="20000"/>
+                    </a:ext>
+                  </a:extLst>
+                </a:gridCol>
+                <a:gridCol w="4448556">
+                  <a:extLst>
+                    <a:ext uri="{9D8B030D-6E8A-4147-A177-3AD203B41FA5}">
+                      <a16:colId xmlns:a16="http://schemas.microsoft.com/office/drawing/2014/main" val="20001"/>
+                    </a:ext>
+                  </a:extLst>
+                </a:gridCol>
+                <a:gridCol w="4448556">
+                  <a:extLst>
+                    <a:ext uri="{9D8B030D-6E8A-4147-A177-3AD203B41FA5}">
+                      <a16:colId xmlns:a16="http://schemas.microsoft.com/office/drawing/2014/main" val="20002"/>
+                    </a:ext>
+                  </a:extLst>
+                </a:gridCol>
               </a:tblGrid>
               <a:tr h="594360">
                 <a:tc>
@@ -3216,7 +3026,7 @@
                     <a:bodyPr/>
                     <a:lstStyle/>
                     <a:p>
-                      <a:pPr indent="0" marL="0">
+                      <a:pPr marL="0" indent="0">
                         <a:buNone/>
                       </a:pPr>
                       <a:endParaRPr lang="en-US" sz="1900" dirty="0"/>
@@ -3269,7 +3079,7 @@
                     <a:bodyPr/>
                     <a:lstStyle/>
                     <a:p>
-                      <a:pPr indent="0" marL="0">
+                      <a:pPr marL="0" indent="0">
                         <a:buNone/>
                       </a:pPr>
                       <a:r>
@@ -3330,7 +3140,7 @@
                     <a:bodyPr/>
                     <a:lstStyle/>
                     <a:p>
-                      <a:pPr indent="0" marL="0">
+                      <a:pPr marL="0" indent="0">
                         <a:buNone/>
                       </a:pPr>
                       <a:r>
@@ -3386,6 +3196,11 @@
                     </a:solidFill>
                   </a:tcPr>
                 </a:tc>
+                <a:extLst>
+                  <a:ext uri="{0D108BD9-81ED-4DB2-BD59-A6C34878D82A}">
+                    <a16:rowId xmlns:a16="http://schemas.microsoft.com/office/drawing/2014/main" val="10000"/>
+                  </a:ext>
+                </a:extLst>
               </a:tr>
               <a:tr h="868680">
                 <a:tc>
@@ -3393,7 +3208,7 @@
                     <a:bodyPr/>
                     <a:lstStyle/>
                     <a:p>
-                      <a:pPr indent="0" marL="0">
+                      <a:pPr marL="0" indent="0">
                         <a:buNone/>
                       </a:pPr>
                       <a:r>
@@ -3451,7 +3266,7 @@
                     <a:bodyPr/>
                     <a:lstStyle/>
                     <a:p>
-                      <a:pPr indent="0" marL="0">
+                      <a:pPr marL="0" indent="0">
                         <a:buNone/>
                       </a:pPr>
                       <a:r>
@@ -3509,7 +3324,7 @@
                     <a:bodyPr/>
                     <a:lstStyle/>
                     <a:p>
-                      <a:pPr indent="0" marL="0">
+                      <a:pPr marL="0" indent="0">
                         <a:buNone/>
                       </a:pPr>
                       <a:r>
@@ -3562,6 +3377,11 @@
                     </a:lnB>
                   </a:tcPr>
                 </a:tc>
+                <a:extLst>
+                  <a:ext uri="{0D108BD9-81ED-4DB2-BD59-A6C34878D82A}">
+                    <a16:rowId xmlns:a16="http://schemas.microsoft.com/office/drawing/2014/main" val="10001"/>
+                  </a:ext>
+                </a:extLst>
               </a:tr>
               <a:tr h="731520">
                 <a:tc>
@@ -3569,7 +3389,7 @@
                     <a:bodyPr/>
                     <a:lstStyle/>
                     <a:p>
-                      <a:pPr indent="0" marL="0">
+                      <a:pPr marL="0" indent="0">
                         <a:buNone/>
                       </a:pPr>
                       <a:r>
@@ -3627,7 +3447,7 @@
                     <a:bodyPr/>
                     <a:lstStyle/>
                     <a:p>
-                      <a:pPr indent="0" marL="0">
+                      <a:pPr marL="0" indent="0">
                         <a:buNone/>
                       </a:pPr>
                       <a:r>
@@ -3685,7 +3505,7 @@
                     <a:bodyPr/>
                     <a:lstStyle/>
                     <a:p>
-                      <a:pPr indent="0" marL="0">
+                      <a:pPr marL="0" indent="0">
                         <a:buNone/>
                       </a:pPr>
                       <a:r>
@@ -3738,6 +3558,11 @@
                     </a:lnB>
                   </a:tcPr>
                 </a:tc>
+                <a:extLst>
+                  <a:ext uri="{0D108BD9-81ED-4DB2-BD59-A6C34878D82A}">
+                    <a16:rowId xmlns:a16="http://schemas.microsoft.com/office/drawing/2014/main" val="10002"/>
+                  </a:ext>
+                </a:extLst>
               </a:tr>
               <a:tr h="868680">
                 <a:tc>
@@ -3745,7 +3570,7 @@
                     <a:bodyPr/>
                     <a:lstStyle/>
                     <a:p>
-                      <a:pPr indent="0" marL="0">
+                      <a:pPr marL="0" indent="0">
                         <a:buNone/>
                       </a:pPr>
                       <a:r>
@@ -3803,7 +3628,7 @@
                     <a:bodyPr/>
                     <a:lstStyle/>
                     <a:p>
-                      <a:pPr indent="0" marL="0">
+                      <a:pPr marL="0" indent="0">
                         <a:buNone/>
                       </a:pPr>
                       <a:r>
@@ -3861,7 +3686,7 @@
                     <a:bodyPr/>
                     <a:lstStyle/>
                     <a:p>
-                      <a:pPr indent="0" marL="0">
+                      <a:pPr marL="0" indent="0">
                         <a:buNone/>
                       </a:pPr>
                       <a:r>
@@ -3914,6 +3739,11 @@
                     </a:lnB>
                   </a:tcPr>
                 </a:tc>
+                <a:extLst>
+                  <a:ext uri="{0D108BD9-81ED-4DB2-BD59-A6C34878D82A}">
+                    <a16:rowId xmlns:a16="http://schemas.microsoft.com/office/drawing/2014/main" val="10003"/>
+                  </a:ext>
+                </a:extLst>
               </a:tr>
               <a:tr h="731520">
                 <a:tc>
@@ -3921,7 +3751,7 @@
                     <a:bodyPr/>
                     <a:lstStyle/>
                     <a:p>
-                      <a:pPr indent="0" marL="0">
+                      <a:pPr marL="0" indent="0">
                         <a:buNone/>
                       </a:pPr>
                       <a:r>
@@ -3979,7 +3809,7 @@
                     <a:bodyPr/>
                     <a:lstStyle/>
                     <a:p>
-                      <a:pPr indent="0" marL="0">
+                      <a:pPr marL="0" indent="0">
                         <a:buNone/>
                       </a:pPr>
                       <a:r>
@@ -4037,7 +3867,7 @@
                     <a:bodyPr/>
                     <a:lstStyle/>
                     <a:p>
-                      <a:pPr indent="0" marL="0">
+                      <a:pPr marL="0" indent="0">
                         <a:buNone/>
                       </a:pPr>
                       <a:r>
@@ -4090,6 +3920,11 @@
                     </a:lnB>
                   </a:tcPr>
                 </a:tc>
+                <a:extLst>
+                  <a:ext uri="{0D108BD9-81ED-4DB2-BD59-A6C34878D82A}">
+                    <a16:rowId xmlns:a16="http://schemas.microsoft.com/office/drawing/2014/main" val="10004"/>
+                  </a:ext>
+                </a:extLst>
               </a:tr>
             </a:tbl>
           </a:graphicData>
@@ -4115,7 +3950,7 @@
           </a:prstGeom>
           <a:extLst>
             <a:ext uri="{C572A759-6A51-4108-AA02-DFA0A04FC94B}">
-              <ma14:wrappingTextBoxFlag xmlns:ma14="http://schemas.microsoft.com/office/mac/drawingml/2011/main" val="0"/>
+              <ma14:wrappingTextBoxFlag xmlns:ma14="http://schemas.microsoft.com/office/mac/drawingml/2011/main" xmlns="" val="0"/>
             </a:ext>
           </a:extLst>
         </p:spPr>
@@ -4133,7 +3968,7 @@
           <a:p>
             <a:pPr algn="r"/>
             <a:fld id="{F7021451-1387-4CA6-816F-3879F97B5CBC}" type="slidenum">
-              <a:rPr b="0" lang="en-US"/>
+              <a:rPr lang="en-US" b="0"/>
               <a:t>11</a:t>
             </a:fld>
             <a:endParaRPr lang="en-US"/>
@@ -4186,7 +4021,7 @@
           <a:bodyPr wrap="square" lIns="0" tIns="0" rIns="0" bIns="0" rtlCol="0" anchor="ctr"/>
           <a:lstStyle/>
           <a:p>
-            <a:pPr indent="0" marL="0">
+            <a:pPr marL="0" indent="0">
               <a:buNone/>
             </a:pPr>
             <a:r>
@@ -4204,9 +4039,11 @@
       <p:sp>
         <p:nvSpPr>
           <p:cNvPr id="3" name="Text 0"/>
-          <p:cNvSpPr/>
+          <p:cNvSpPr>
+            <a:spLocks noGrp="1"/>
+          </p:cNvSpPr>
           <p:nvPr>
-            <p:ph idx="100" type="body" hasCustomPrompt="1"/>
+            <p:ph type="body" idx="100" hasCustomPrompt="1"/>
           </p:nvPr>
         </p:nvSpPr>
         <p:spPr>
@@ -4224,7 +4061,7 @@
           <a:bodyPr wrap="square" lIns="0" tIns="0" rIns="0" bIns="0" rtlCol="0" anchor="ctr"/>
           <a:lstStyle/>
           <a:p>
-            <a:pPr indent="0" marL="0">
+            <a:pPr marL="0" indent="0">
               <a:buNone/>
             </a:pPr>
             <a:r>
@@ -4238,7 +4075,7 @@
             <a:endParaRPr lang="en-US" sz="3400" dirty="0"/>
           </a:p>
           <a:p>
-            <a:pPr indent="0" marL="0">
+            <a:pPr marL="0" indent="0">
               <a:buNone/>
             </a:pPr>
             <a:r>
@@ -4273,7 +4110,7 @@
           </a:prstGeom>
           <a:extLst>
             <a:ext uri="{C572A759-6A51-4108-AA02-DFA0A04FC94B}">
-              <ma14:wrappingTextBoxFlag xmlns:ma14="http://schemas.microsoft.com/office/mac/drawingml/2011/main" val="0"/>
+              <ma14:wrappingTextBoxFlag xmlns:ma14="http://schemas.microsoft.com/office/mac/drawingml/2011/main" xmlns="" val="0"/>
             </a:ext>
           </a:extLst>
         </p:spPr>
@@ -4291,7 +4128,7 @@
           <a:p>
             <a:pPr algn="r"/>
             <a:fld id="{F7021451-1387-4CA6-816F-3879F97B5CBC}" type="slidenum">
-              <a:rPr b="0" lang="en-US"/>
+              <a:rPr lang="en-US" b="0"/>
               <a:t>12</a:t>
             </a:fld>
             <a:endParaRPr lang="en-US"/>
@@ -4326,9 +4163,11 @@
       <p:sp>
         <p:nvSpPr>
           <p:cNvPr id="2" name="Text 0"/>
-          <p:cNvSpPr/>
+          <p:cNvSpPr>
+            <a:spLocks noGrp="1"/>
+          </p:cNvSpPr>
           <p:nvPr>
-            <p:ph idx="100" type="title" hasCustomPrompt="1"/>
+            <p:ph type="title" idx="100" hasCustomPrompt="1"/>
           </p:nvPr>
         </p:nvSpPr>
         <p:spPr>
@@ -4346,7 +4185,7 @@
           <a:bodyPr wrap="square" lIns="0" tIns="0" rIns="0" bIns="0" rtlCol="0" anchor="ctr"/>
           <a:lstStyle/>
           <a:p>
-            <a:pPr algn="l" indent="0" marL="0">
+            <a:pPr marL="0" indent="0" algn="l">
               <a:buNone/>
             </a:pPr>
             <a:r>
@@ -4383,14 +4222,14 @@
       </p:sp>
       <p:pic>
         <p:nvPicPr>
-          <p:cNvPr id="4" name="Image 0" descr="Fuentes">    </p:cNvPr>
+          <p:cNvPr id="4" name="Image 0" descr="Fuentes"/>
           <p:cNvPicPr>
             <a:picLocks noChangeAspect="1"/>
           </p:cNvPicPr>
           <p:nvPr/>
         </p:nvPicPr>
         <p:blipFill>
-          <a:blip r:embed="rId1"/>
+          <a:blip r:embed="rId3"/>
           <a:stretch>
             <a:fillRect/>
           </a:stretch>
@@ -4426,7 +4265,7 @@
           <a:bodyPr wrap="square" lIns="0" tIns="0" rIns="0" bIns="0" rtlCol="0" anchor="t"/>
           <a:lstStyle/>
           <a:p>
-            <a:pPr indent="0" marL="0">
+            <a:pPr marL="0" indent="0">
               <a:buNone/>
             </a:pPr>
             <a:r>
@@ -4440,7 +4279,7 @@
             <a:endParaRPr lang="en-US" sz="1500" dirty="0"/>
           </a:p>
           <a:p>
-            <a:pPr indent="0" marL="0">
+            <a:pPr marL="0" indent="0">
               <a:spcAft>
                 <a:spcPts val="1000"/>
               </a:spcAft>
@@ -4451,7 +4290,7 @@
                 <a:solidFill>
                   <a:schemeClr val="accent2"/>
                 </a:solidFill>
-                <a:hlinkClick r:id="rId2" invalidUrl="" action="" tgtFrame="" tooltip="" history="1" highlightClick="0" endSnd="0">
+                <a:hlinkClick r:id="rId4">
                   <a:extLst>
                     <a:ext uri="{A12FA001-AC4F-418D-AE19-62706E023703}">
                       <ahyp:hlinkClr xmlns:ahyp="http://schemas.microsoft.com/office/drawing/2018/hyperlinkcolor" val="tx"/>
@@ -4464,7 +4303,7 @@
             <a:endParaRPr lang="en-US" sz="1500" dirty="0"/>
           </a:p>
           <a:p>
-            <a:pPr indent="0" marL="0">
+            <a:pPr marL="0" indent="0">
               <a:buNone/>
             </a:pPr>
             <a:r>
@@ -4478,7 +4317,7 @@
             <a:endParaRPr lang="en-US" sz="1500" dirty="0"/>
           </a:p>
           <a:p>
-            <a:pPr indent="0" marL="0">
+            <a:pPr marL="0" indent="0">
               <a:spcAft>
                 <a:spcPts val="1000"/>
               </a:spcAft>
@@ -4489,7 +4328,7 @@
                 <a:solidFill>
                   <a:schemeClr val="accent2"/>
                 </a:solidFill>
-                <a:hlinkClick r:id="rId3" invalidUrl="" action="" tgtFrame="" tooltip="" history="1" highlightClick="0" endSnd="0">
+                <a:hlinkClick r:id="rId5">
                   <a:extLst>
                     <a:ext uri="{A12FA001-AC4F-418D-AE19-62706E023703}">
                       <ahyp:hlinkClr xmlns:ahyp="http://schemas.microsoft.com/office/drawing/2018/hyperlinkcolor" val="tx"/>
@@ -4502,7 +4341,7 @@
             <a:endParaRPr lang="en-US" sz="1500" dirty="0"/>
           </a:p>
           <a:p>
-            <a:pPr indent="0" marL="0">
+            <a:pPr marL="0" indent="0">
               <a:buNone/>
             </a:pPr>
             <a:r>
@@ -4516,7 +4355,7 @@
             <a:endParaRPr lang="en-US" sz="1500" dirty="0"/>
           </a:p>
           <a:p>
-            <a:pPr indent="0" marL="0">
+            <a:pPr marL="0" indent="0">
               <a:spcAft>
                 <a:spcPts val="1000"/>
               </a:spcAft>
@@ -4527,7 +4366,7 @@
                 <a:solidFill>
                   <a:schemeClr val="accent2"/>
                 </a:solidFill>
-                <a:hlinkClick r:id="rId4" invalidUrl="" action="" tgtFrame="" tooltip="" history="1" highlightClick="0" endSnd="0">
+                <a:hlinkClick r:id="rId6">
                   <a:extLst>
                     <a:ext uri="{A12FA001-AC4F-418D-AE19-62706E023703}">
                       <ahyp:hlinkClr xmlns:ahyp="http://schemas.microsoft.com/office/drawing/2018/hyperlinkcolor" val="tx"/>
@@ -4540,7 +4379,7 @@
             <a:endParaRPr lang="en-US" sz="1500" dirty="0"/>
           </a:p>
           <a:p>
-            <a:pPr indent="0" marL="0">
+            <a:pPr marL="0" indent="0">
               <a:buNone/>
             </a:pPr>
             <a:r>
@@ -4554,7 +4393,7 @@
             <a:endParaRPr lang="en-US" sz="1500" dirty="0"/>
           </a:p>
           <a:p>
-            <a:pPr indent="0" marL="0">
+            <a:pPr marL="0" indent="0">
               <a:spcAft>
                 <a:spcPts val="1000"/>
               </a:spcAft>
@@ -4565,7 +4404,7 @@
                 <a:solidFill>
                   <a:schemeClr val="accent2"/>
                 </a:solidFill>
-                <a:hlinkClick r:id="rId5" invalidUrl="" action="" tgtFrame="" tooltip="" history="1" highlightClick="0" endSnd="0">
+                <a:hlinkClick r:id="rId7">
                   <a:extLst>
                     <a:ext uri="{A12FA001-AC4F-418D-AE19-62706E023703}">
                       <ahyp:hlinkClr xmlns:ahyp="http://schemas.microsoft.com/office/drawing/2018/hyperlinkcolor" val="tx"/>
@@ -4578,7 +4417,7 @@
             <a:endParaRPr lang="en-US" sz="1500" dirty="0"/>
           </a:p>
           <a:p>
-            <a:pPr indent="0" marL="0">
+            <a:pPr marL="0" indent="0">
               <a:buNone/>
             </a:pPr>
             <a:r>
@@ -4592,7 +4431,7 @@
             <a:endParaRPr lang="en-US" sz="1500" dirty="0"/>
           </a:p>
           <a:p>
-            <a:pPr indent="0" marL="0">
+            <a:pPr marL="0" indent="0">
               <a:spcAft>
                 <a:spcPts val="1000"/>
               </a:spcAft>
@@ -4603,7 +4442,7 @@
                 <a:solidFill>
                   <a:schemeClr val="accent2"/>
                 </a:solidFill>
-                <a:hlinkClick r:id="rId6" invalidUrl="" action="" tgtFrame="" tooltip="" history="1" highlightClick="0" endSnd="0">
+                <a:hlinkClick r:id="rId8">
                   <a:extLst>
                     <a:ext uri="{A12FA001-AC4F-418D-AE19-62706E023703}">
                       <ahyp:hlinkClr xmlns:ahyp="http://schemas.microsoft.com/office/drawing/2018/hyperlinkcolor" val="tx"/>
@@ -4637,7 +4476,7 @@
           </a:prstGeom>
           <a:extLst>
             <a:ext uri="{C572A759-6A51-4108-AA02-DFA0A04FC94B}">
-              <ma14:wrappingTextBoxFlag xmlns:ma14="http://schemas.microsoft.com/office/mac/drawingml/2011/main" val="0"/>
+              <ma14:wrappingTextBoxFlag xmlns:ma14="http://schemas.microsoft.com/office/mac/drawingml/2011/main" xmlns="" val="0"/>
             </a:ext>
           </a:extLst>
         </p:spPr>
@@ -4655,7 +4494,7 @@
           <a:p>
             <a:pPr algn="r"/>
             <a:fld id="{F7021451-1387-4CA6-816F-3879F97B5CBC}" type="slidenum">
-              <a:rPr b="0" lang="en-US"/>
+              <a:rPr lang="en-US" b="0"/>
               <a:t>13</a:t>
             </a:fld>
             <a:endParaRPr lang="en-US"/>
@@ -4690,9 +4529,11 @@
       <p:sp>
         <p:nvSpPr>
           <p:cNvPr id="2" name="Text 0"/>
-          <p:cNvSpPr/>
+          <p:cNvSpPr>
+            <a:spLocks noGrp="1"/>
+          </p:cNvSpPr>
           <p:nvPr>
-            <p:ph idx="100" type="body" hasCustomPrompt="1"/>
+            <p:ph type="body" idx="100" hasCustomPrompt="1"/>
           </p:nvPr>
         </p:nvSpPr>
         <p:spPr>
@@ -4710,7 +4551,7 @@
           <a:bodyPr wrap="square" lIns="0" tIns="0" rIns="0" bIns="0" rtlCol="0" anchor="ctr"/>
           <a:lstStyle/>
           <a:p>
-            <a:pPr indent="0" marL="0">
+            <a:pPr marL="0" indent="0">
               <a:buNone/>
             </a:pPr>
             <a:r>
@@ -4724,7 +4565,7 @@
             <a:endParaRPr lang="en-US" sz="3400" dirty="0"/>
           </a:p>
           <a:p>
-            <a:pPr indent="0" marL="0">
+            <a:pPr marL="0" indent="0">
               <a:buNone/>
             </a:pPr>
             <a:r>
@@ -4759,7 +4600,7 @@
           </a:prstGeom>
           <a:extLst>
             <a:ext uri="{C572A759-6A51-4108-AA02-DFA0A04FC94B}">
-              <ma14:wrappingTextBoxFlag xmlns:ma14="http://schemas.microsoft.com/office/mac/drawingml/2011/main" val="0"/>
+              <ma14:wrappingTextBoxFlag xmlns:ma14="http://schemas.microsoft.com/office/mac/drawingml/2011/main" xmlns="" val="0"/>
             </a:ext>
           </a:extLst>
         </p:spPr>
@@ -4777,7 +4618,7 @@
           <a:p>
             <a:pPr algn="r"/>
             <a:fld id="{F7021451-1387-4CA6-816F-3879F97B5CBC}" type="slidenum">
-              <a:rPr b="0" lang="en-US"/>
+              <a:rPr lang="en-US" b="0"/>
               <a:t>2</a:t>
             </a:fld>
             <a:endParaRPr lang="en-US"/>
@@ -4812,9 +4653,11 @@
       <p:sp>
         <p:nvSpPr>
           <p:cNvPr id="2" name="Text 0"/>
-          <p:cNvSpPr/>
+          <p:cNvSpPr>
+            <a:spLocks noGrp="1"/>
+          </p:cNvSpPr>
           <p:nvPr>
-            <p:ph idx="100" type="title" hasCustomPrompt="1"/>
+            <p:ph type="title" idx="100" hasCustomPrompt="1"/>
           </p:nvPr>
         </p:nvSpPr>
         <p:spPr>
@@ -4832,7 +4675,7 @@
           <a:bodyPr wrap="square" lIns="0" tIns="0" rIns="0" bIns="0" rtlCol="0" anchor="ctr"/>
           <a:lstStyle/>
           <a:p>
-            <a:pPr algn="l" indent="0" marL="0">
+            <a:pPr marL="0" indent="0" algn="l">
               <a:buNone/>
             </a:pPr>
             <a:r>
@@ -4868,7 +4711,7 @@
           <a:bodyPr wrap="square" lIns="0" tIns="0" rIns="0" bIns="0" rtlCol="0" anchor="ctr"/>
           <a:lstStyle/>
           <a:p>
-            <a:pPr indent="0" marL="0">
+            <a:pPr marL="0" indent="0">
               <a:buNone/>
             </a:pPr>
             <a:r>
@@ -4927,283 +4770,7 @@
       </p:sp>
       <p:pic>
         <p:nvPicPr>
-          <p:cNvPr id="6" name="Image 0" descr="Lumen">    </p:cNvPr>
-          <p:cNvPicPr>
-            <a:picLocks noChangeAspect="1"/>
-          </p:cNvPicPr>
-          <p:nvPr/>
-        </p:nvPicPr>
-        <p:blipFill>
-          <a:blip r:embed="rId1"/>
-          <a:stretch>
-            <a:fillRect/>
-          </a:stretch>
-        </p:blipFill>
-        <p:spPr>
-          <a:xfrm>
-            <a:off x="1088136" y="2505456"/>
-            <a:ext cx="475488" cy="475488"/>
-          </a:xfrm>
-          <a:prstGeom prst="rect">
-            <a:avLst/>
-          </a:prstGeom>
-        </p:spPr>
-      </p:pic>
-      <p:sp>
-        <p:nvSpPr>
-          <p:cNvPr id="7" name="Text 4"/>
-          <p:cNvSpPr txBox="1"/>
-          <p:nvPr/>
-        </p:nvSpPr>
-        <p:spPr>
-          <a:xfrm>
-            <a:off x="1965960" y="2286000"/>
-            <a:ext cx="1808378" cy="914400"/>
-          </a:xfrm>
-          <a:prstGeom prst="rect">
-            <a:avLst/>
-          </a:prstGeom>
-          <a:noFill/>
-          <a:ln/>
-        </p:spPr>
-        <p:txBody>
-          <a:bodyPr wrap="square" lIns="0" tIns="0" rIns="0" bIns="0" rtlCol="0" anchor="ctr"/>
-          <a:lstStyle/>
-          <a:p>
-            <a:pPr indent="0" marL="0">
-              <a:buNone/>
-            </a:pPr>
-            <a:r>
-              <a:rPr lang="en-US" sz="2600" b="1" dirty="0">
-                <a:solidFill>
-                  <a:schemeClr val="tx1"/>
-                </a:solidFill>
-              </a:rPr>
-              <a:t>Lumen</a:t>
-            </a:r>
-            <a:endParaRPr lang="en-US" sz="2600" dirty="0"/>
-          </a:p>
-        </p:txBody>
-      </p:sp>
-      <p:sp>
-        <p:nvSpPr>
-          <p:cNvPr id="8" name="Text 5"/>
-          <p:cNvSpPr txBox="1"/>
-          <p:nvPr/>
-        </p:nvSpPr>
-        <p:spPr>
-          <a:xfrm>
-            <a:off x="868680" y="3383280"/>
-            <a:ext cx="2814218" cy="960120"/>
-          </a:xfrm>
-          <a:prstGeom prst="rect">
-            <a:avLst/>
-          </a:prstGeom>
-          <a:noFill/>
-          <a:ln/>
-        </p:spPr>
-        <p:txBody>
-          <a:bodyPr wrap="square" lIns="0" tIns="0" rIns="0" bIns="0" rtlCol="0" anchor="t"/>
-          <a:lstStyle/>
-          <a:p>
-            <a:pPr indent="0" marL="0">
-              <a:buNone/>
-            </a:pPr>
-            <a:r>
-              <a:rPr lang="en-US" sz="1800" dirty="0">
-                <a:solidFill>
-                  <a:schemeClr val="tx1"/>
-                </a:solidFill>
-              </a:rPr>
-              <a:t>La luz, las sombras y los reflejos se calculan solos y en tiempo real.</a:t>
-            </a:r>
-            <a:endParaRPr lang="en-US" sz="1800" dirty="0"/>
-          </a:p>
-        </p:txBody>
-      </p:sp>
-      <p:sp>
-        <p:nvSpPr>
-          <p:cNvPr id="9" name="Tarjeta"/>
-          <p:cNvSpPr/>
-          <p:nvPr/>
-        </p:nvSpPr>
-        <p:spPr>
-          <a:xfrm>
-            <a:off x="4368698" y="2011680"/>
-            <a:ext cx="3454298" cy="2468880"/>
-          </a:xfrm>
-          <a:prstGeom prst="roundRect">
-            <a:avLst>
-              <a:gd name="adj" fmla="val 5556"/>
-            </a:avLst>
-          </a:prstGeom>
-          <a:solidFill>
-            <a:schemeClr val="bg2"/>
-          </a:solidFill>
-          <a:ln/>
-        </p:spPr>
-      </p:sp>
-      <p:sp>
-        <p:nvSpPr>
-          <p:cNvPr id="10" name="Nanite"/>
-          <p:cNvSpPr/>
-          <p:nvPr/>
-        </p:nvSpPr>
-        <p:spPr>
-          <a:xfrm>
-            <a:off x="4688738" y="2286000"/>
-            <a:ext cx="914400" cy="914400"/>
-          </a:xfrm>
-          <a:prstGeom prst="ellipse">
-            <a:avLst/>
-          </a:prstGeom>
-          <a:solidFill>
-            <a:schemeClr val="accent3"/>
-          </a:solidFill>
-          <a:ln/>
-        </p:spPr>
-      </p:sp>
-      <p:pic>
-        <p:nvPicPr>
-          <p:cNvPr id="11" name="Image 1" descr="Nanite">    </p:cNvPr>
-          <p:cNvPicPr>
-            <a:picLocks noChangeAspect="1"/>
-          </p:cNvPicPr>
-          <p:nvPr/>
-        </p:nvPicPr>
-        <p:blipFill>
-          <a:blip r:embed="rId2"/>
-          <a:stretch>
-            <a:fillRect/>
-          </a:stretch>
-        </p:blipFill>
-        <p:spPr>
-          <a:xfrm>
-            <a:off x="4908194" y="2505456"/>
-            <a:ext cx="475488" cy="475488"/>
-          </a:xfrm>
-          <a:prstGeom prst="rect">
-            <a:avLst/>
-          </a:prstGeom>
-        </p:spPr>
-      </p:pic>
-      <p:sp>
-        <p:nvSpPr>
-          <p:cNvPr id="12" name="Text 8"/>
-          <p:cNvSpPr txBox="1"/>
-          <p:nvPr/>
-        </p:nvSpPr>
-        <p:spPr>
-          <a:xfrm>
-            <a:off x="5786018" y="2286000"/>
-            <a:ext cx="1808378" cy="914400"/>
-          </a:xfrm>
-          <a:prstGeom prst="rect">
-            <a:avLst/>
-          </a:prstGeom>
-          <a:noFill/>
-          <a:ln/>
-        </p:spPr>
-        <p:txBody>
-          <a:bodyPr wrap="square" lIns="0" tIns="0" rIns="0" bIns="0" rtlCol="0" anchor="ctr"/>
-          <a:lstStyle/>
-          <a:p>
-            <a:pPr indent="0" marL="0">
-              <a:buNone/>
-            </a:pPr>
-            <a:r>
-              <a:rPr lang="en-US" sz="2600" b="1" dirty="0">
-                <a:solidFill>
-                  <a:schemeClr val="tx1"/>
-                </a:solidFill>
-              </a:rPr>
-              <a:t>Nanite</a:t>
-            </a:r>
-            <a:endParaRPr lang="en-US" sz="2600" dirty="0"/>
-          </a:p>
-        </p:txBody>
-      </p:sp>
-      <p:sp>
-        <p:nvSpPr>
-          <p:cNvPr id="13" name="Text 9"/>
-          <p:cNvSpPr txBox="1"/>
-          <p:nvPr/>
-        </p:nvSpPr>
-        <p:spPr>
-          <a:xfrm>
-            <a:off x="4688738" y="3383280"/>
-            <a:ext cx="2814218" cy="960120"/>
-          </a:xfrm>
-          <a:prstGeom prst="rect">
-            <a:avLst/>
-          </a:prstGeom>
-          <a:noFill/>
-          <a:ln/>
-        </p:spPr>
-        <p:txBody>
-          <a:bodyPr wrap="square" lIns="0" tIns="0" rIns="0" bIns="0" rtlCol="0" anchor="t"/>
-          <a:lstStyle/>
-          <a:p>
-            <a:pPr indent="0" marL="0">
-              <a:buNone/>
-            </a:pPr>
-            <a:r>
-              <a:rPr lang="en-US" sz="1800" dirty="0">
-                <a:solidFill>
-                  <a:schemeClr val="tx1"/>
-                </a:solidFill>
-              </a:rPr>
-              <a:t>Objetos con un detalle casi ilimitado, incluso escaneados del mundo real.</a:t>
-            </a:r>
-            <a:endParaRPr lang="en-US" sz="1800" dirty="0"/>
-          </a:p>
-        </p:txBody>
-      </p:sp>
-      <p:sp>
-        <p:nvSpPr>
-          <p:cNvPr id="14" name="Tarjeta"/>
-          <p:cNvSpPr/>
-          <p:nvPr/>
-        </p:nvSpPr>
-        <p:spPr>
-          <a:xfrm>
-            <a:off x="8188757" y="2011680"/>
-            <a:ext cx="3454298" cy="2468880"/>
-          </a:xfrm>
-          <a:prstGeom prst="roundRect">
-            <a:avLst>
-              <a:gd name="adj" fmla="val 5556"/>
-            </a:avLst>
-          </a:prstGeom>
-          <a:solidFill>
-            <a:schemeClr val="bg2"/>
-          </a:solidFill>
-          <a:ln/>
-        </p:spPr>
-      </p:sp>
-      <p:sp>
-        <p:nvSpPr>
-          <p:cNvPr id="15" name="Megascans"/>
-          <p:cNvSpPr/>
-          <p:nvPr/>
-        </p:nvSpPr>
-        <p:spPr>
-          <a:xfrm>
-            <a:off x="8508797" y="2286000"/>
-            <a:ext cx="914400" cy="914400"/>
-          </a:xfrm>
-          <a:prstGeom prst="ellipse">
-            <a:avLst/>
-          </a:prstGeom>
-          <a:solidFill>
-            <a:schemeClr val="accent4"/>
-          </a:solidFill>
-          <a:ln/>
-        </p:spPr>
-      </p:sp>
-      <p:pic>
-        <p:nvPicPr>
-          <p:cNvPr id="16" name="Image 2" descr="Megascans">    </p:cNvPr>
+          <p:cNvPr id="6" name="Image 0" descr="Lumen"/>
           <p:cNvPicPr>
             <a:picLocks noChangeAspect="1"/>
           </p:cNvPicPr>
@@ -5217,6 +4784,282 @@
         </p:blipFill>
         <p:spPr>
           <a:xfrm>
+            <a:off x="1088136" y="2505456"/>
+            <a:ext cx="475488" cy="475488"/>
+          </a:xfrm>
+          <a:prstGeom prst="rect">
+            <a:avLst/>
+          </a:prstGeom>
+        </p:spPr>
+      </p:pic>
+      <p:sp>
+        <p:nvSpPr>
+          <p:cNvPr id="7" name="Text 4"/>
+          <p:cNvSpPr txBox="1"/>
+          <p:nvPr/>
+        </p:nvSpPr>
+        <p:spPr>
+          <a:xfrm>
+            <a:off x="1965960" y="2286000"/>
+            <a:ext cx="1808378" cy="914400"/>
+          </a:xfrm>
+          <a:prstGeom prst="rect">
+            <a:avLst/>
+          </a:prstGeom>
+          <a:noFill/>
+          <a:ln/>
+        </p:spPr>
+        <p:txBody>
+          <a:bodyPr wrap="square" lIns="0" tIns="0" rIns="0" bIns="0" rtlCol="0" anchor="ctr"/>
+          <a:lstStyle/>
+          <a:p>
+            <a:pPr marL="0" indent="0">
+              <a:buNone/>
+            </a:pPr>
+            <a:r>
+              <a:rPr lang="en-US" sz="2600" b="1" dirty="0">
+                <a:solidFill>
+                  <a:schemeClr val="tx1"/>
+                </a:solidFill>
+              </a:rPr>
+              <a:t>Lumen</a:t>
+            </a:r>
+            <a:endParaRPr lang="en-US" sz="2600" dirty="0"/>
+          </a:p>
+        </p:txBody>
+      </p:sp>
+      <p:sp>
+        <p:nvSpPr>
+          <p:cNvPr id="8" name="Text 5"/>
+          <p:cNvSpPr txBox="1"/>
+          <p:nvPr/>
+        </p:nvSpPr>
+        <p:spPr>
+          <a:xfrm>
+            <a:off x="868680" y="3383280"/>
+            <a:ext cx="2814218" cy="960120"/>
+          </a:xfrm>
+          <a:prstGeom prst="rect">
+            <a:avLst/>
+          </a:prstGeom>
+          <a:noFill/>
+          <a:ln/>
+        </p:spPr>
+        <p:txBody>
+          <a:bodyPr wrap="square" lIns="0" tIns="0" rIns="0" bIns="0" rtlCol="0" anchor="t"/>
+          <a:lstStyle/>
+          <a:p>
+            <a:pPr marL="0" indent="0">
+              <a:buNone/>
+            </a:pPr>
+            <a:r>
+              <a:rPr lang="en-US" sz="1800" dirty="0">
+                <a:solidFill>
+                  <a:schemeClr val="tx1"/>
+                </a:solidFill>
+              </a:rPr>
+              <a:t>La luz, las sombras y los reflejos se calculan solos y en tiempo real.</a:t>
+            </a:r>
+            <a:endParaRPr lang="en-US" sz="1800" dirty="0"/>
+          </a:p>
+        </p:txBody>
+      </p:sp>
+      <p:sp>
+        <p:nvSpPr>
+          <p:cNvPr id="9" name="Tarjeta"/>
+          <p:cNvSpPr/>
+          <p:nvPr/>
+        </p:nvSpPr>
+        <p:spPr>
+          <a:xfrm>
+            <a:off x="4368698" y="2011680"/>
+            <a:ext cx="3454298" cy="2468880"/>
+          </a:xfrm>
+          <a:prstGeom prst="roundRect">
+            <a:avLst>
+              <a:gd name="adj" fmla="val 5556"/>
+            </a:avLst>
+          </a:prstGeom>
+          <a:solidFill>
+            <a:schemeClr val="bg2"/>
+          </a:solidFill>
+          <a:ln/>
+        </p:spPr>
+      </p:sp>
+      <p:sp>
+        <p:nvSpPr>
+          <p:cNvPr id="10" name="Nanite"/>
+          <p:cNvSpPr/>
+          <p:nvPr/>
+        </p:nvSpPr>
+        <p:spPr>
+          <a:xfrm>
+            <a:off x="4688738" y="2286000"/>
+            <a:ext cx="914400" cy="914400"/>
+          </a:xfrm>
+          <a:prstGeom prst="ellipse">
+            <a:avLst/>
+          </a:prstGeom>
+          <a:solidFill>
+            <a:schemeClr val="accent3"/>
+          </a:solidFill>
+          <a:ln/>
+        </p:spPr>
+      </p:sp>
+      <p:pic>
+        <p:nvPicPr>
+          <p:cNvPr id="11" name="Image 1" descr="Nanite"/>
+          <p:cNvPicPr>
+            <a:picLocks noChangeAspect="1"/>
+          </p:cNvPicPr>
+          <p:nvPr/>
+        </p:nvPicPr>
+        <p:blipFill>
+          <a:blip r:embed="rId4"/>
+          <a:stretch>
+            <a:fillRect/>
+          </a:stretch>
+        </p:blipFill>
+        <p:spPr>
+          <a:xfrm>
+            <a:off x="4908194" y="2505456"/>
+            <a:ext cx="475488" cy="475488"/>
+          </a:xfrm>
+          <a:prstGeom prst="rect">
+            <a:avLst/>
+          </a:prstGeom>
+        </p:spPr>
+      </p:pic>
+      <p:sp>
+        <p:nvSpPr>
+          <p:cNvPr id="12" name="Text 8"/>
+          <p:cNvSpPr txBox="1"/>
+          <p:nvPr/>
+        </p:nvSpPr>
+        <p:spPr>
+          <a:xfrm>
+            <a:off x="5786018" y="2286000"/>
+            <a:ext cx="1808378" cy="914400"/>
+          </a:xfrm>
+          <a:prstGeom prst="rect">
+            <a:avLst/>
+          </a:prstGeom>
+          <a:noFill/>
+          <a:ln/>
+        </p:spPr>
+        <p:txBody>
+          <a:bodyPr wrap="square" lIns="0" tIns="0" rIns="0" bIns="0" rtlCol="0" anchor="ctr"/>
+          <a:lstStyle/>
+          <a:p>
+            <a:pPr marL="0" indent="0">
+              <a:buNone/>
+            </a:pPr>
+            <a:r>
+              <a:rPr lang="en-US" sz="2600" b="1" dirty="0">
+                <a:solidFill>
+                  <a:schemeClr val="tx1"/>
+                </a:solidFill>
+              </a:rPr>
+              <a:t>Nanite</a:t>
+            </a:r>
+            <a:endParaRPr lang="en-US" sz="2600" dirty="0"/>
+          </a:p>
+        </p:txBody>
+      </p:sp>
+      <p:sp>
+        <p:nvSpPr>
+          <p:cNvPr id="13" name="Text 9"/>
+          <p:cNvSpPr txBox="1"/>
+          <p:nvPr/>
+        </p:nvSpPr>
+        <p:spPr>
+          <a:xfrm>
+            <a:off x="4688738" y="3383280"/>
+            <a:ext cx="2814218" cy="960120"/>
+          </a:xfrm>
+          <a:prstGeom prst="rect">
+            <a:avLst/>
+          </a:prstGeom>
+          <a:noFill/>
+          <a:ln/>
+        </p:spPr>
+        <p:txBody>
+          <a:bodyPr wrap="square" lIns="0" tIns="0" rIns="0" bIns="0" rtlCol="0" anchor="t"/>
+          <a:lstStyle/>
+          <a:p>
+            <a:pPr marL="0" indent="0">
+              <a:buNone/>
+            </a:pPr>
+            <a:r>
+              <a:rPr lang="en-US" sz="1800" dirty="0">
+                <a:solidFill>
+                  <a:schemeClr val="tx1"/>
+                </a:solidFill>
+              </a:rPr>
+              <a:t>Objetos con un detalle casi ilimitado, incluso escaneados del mundo real.</a:t>
+            </a:r>
+            <a:endParaRPr lang="en-US" sz="1800" dirty="0"/>
+          </a:p>
+        </p:txBody>
+      </p:sp>
+      <p:sp>
+        <p:nvSpPr>
+          <p:cNvPr id="14" name="Tarjeta"/>
+          <p:cNvSpPr/>
+          <p:nvPr/>
+        </p:nvSpPr>
+        <p:spPr>
+          <a:xfrm>
+            <a:off x="8188757" y="2011680"/>
+            <a:ext cx="3454298" cy="2468880"/>
+          </a:xfrm>
+          <a:prstGeom prst="roundRect">
+            <a:avLst>
+              <a:gd name="adj" fmla="val 5556"/>
+            </a:avLst>
+          </a:prstGeom>
+          <a:solidFill>
+            <a:schemeClr val="bg2"/>
+          </a:solidFill>
+          <a:ln/>
+        </p:spPr>
+      </p:sp>
+      <p:sp>
+        <p:nvSpPr>
+          <p:cNvPr id="15" name="Megascans"/>
+          <p:cNvSpPr/>
+          <p:nvPr/>
+        </p:nvSpPr>
+        <p:spPr>
+          <a:xfrm>
+            <a:off x="8508797" y="2286000"/>
+            <a:ext cx="914400" cy="914400"/>
+          </a:xfrm>
+          <a:prstGeom prst="ellipse">
+            <a:avLst/>
+          </a:prstGeom>
+          <a:solidFill>
+            <a:schemeClr val="accent4"/>
+          </a:solidFill>
+          <a:ln/>
+        </p:spPr>
+      </p:sp>
+      <p:pic>
+        <p:nvPicPr>
+          <p:cNvPr id="16" name="Image 2" descr="Megascans"/>
+          <p:cNvPicPr>
+            <a:picLocks noChangeAspect="1"/>
+          </p:cNvPicPr>
+          <p:nvPr/>
+        </p:nvPicPr>
+        <p:blipFill>
+          <a:blip r:embed="rId5"/>
+          <a:stretch>
+            <a:fillRect/>
+          </a:stretch>
+        </p:blipFill>
+        <p:spPr>
+          <a:xfrm>
             <a:off x="8728253" y="2505456"/>
             <a:ext cx="475488" cy="475488"/>
           </a:xfrm>
@@ -5246,7 +5089,7 @@
           <a:bodyPr wrap="square" lIns="0" tIns="0" rIns="0" bIns="0" rtlCol="0" anchor="ctr"/>
           <a:lstStyle/>
           <a:p>
-            <a:pPr indent="0" marL="0">
+            <a:pPr marL="0" indent="0">
               <a:buNone/>
             </a:pPr>
             <a:r>
@@ -5282,7 +5125,7 @@
           <a:bodyPr wrap="square" lIns="0" tIns="0" rIns="0" bIns="0" rtlCol="0" anchor="t"/>
           <a:lstStyle/>
           <a:p>
-            <a:pPr indent="0" marL="0">
+            <a:pPr marL="0" indent="0">
               <a:buNone/>
             </a:pPr>
             <a:r>
@@ -5361,7 +5204,7 @@
           <a:bodyPr wrap="square" lIns="0" tIns="0" rIns="0" bIns="0" rtlCol="0" anchor="t"/>
           <a:lstStyle/>
           <a:p>
-            <a:pPr algn="ctr" indent="0" marL="0">
+            <a:pPr marL="0" indent="0" algn="ctr">
               <a:buNone/>
             </a:pPr>
             <a:r>
@@ -5375,7 +5218,7 @@
             <a:endParaRPr lang="en-US" sz="1400" dirty="0"/>
           </a:p>
           <a:p>
-            <a:pPr algn="ctr" indent="0" marL="0">
+            <a:pPr marL="0" indent="0" algn="ctr">
               <a:buNone/>
             </a:pPr>
             <a:r>
@@ -5431,7 +5274,7 @@
           <a:bodyPr wrap="square" lIns="0" tIns="0" rIns="0" bIns="0" rtlCol="0" anchor="t"/>
           <a:lstStyle/>
           <a:p>
-            <a:pPr algn="ctr" indent="0" marL="0">
+            <a:pPr marL="0" indent="0" algn="ctr">
               <a:buNone/>
             </a:pPr>
             <a:r>
@@ -5445,7 +5288,7 @@
             <a:endParaRPr lang="en-US" sz="1400" dirty="0"/>
           </a:p>
           <a:p>
-            <a:pPr algn="ctr" indent="0" marL="0">
+            <a:pPr marL="0" indent="0" algn="ctr">
               <a:buNone/>
             </a:pPr>
             <a:r>
@@ -5501,7 +5344,7 @@
           <a:bodyPr wrap="square" lIns="0" tIns="0" rIns="0" bIns="0" rtlCol="0" anchor="t"/>
           <a:lstStyle/>
           <a:p>
-            <a:pPr algn="ctr" indent="0" marL="0">
+            <a:pPr marL="0" indent="0" algn="ctr">
               <a:buNone/>
             </a:pPr>
             <a:r>
@@ -5515,7 +5358,7 @@
             <a:endParaRPr lang="en-US" sz="1400" dirty="0"/>
           </a:p>
           <a:p>
-            <a:pPr algn="ctr" indent="0" marL="0">
+            <a:pPr marL="0" indent="0" algn="ctr">
               <a:buNone/>
             </a:pPr>
             <a:r>
@@ -5571,7 +5414,7 @@
           <a:bodyPr wrap="square" lIns="0" tIns="0" rIns="0" bIns="0" rtlCol="0" anchor="t"/>
           <a:lstStyle/>
           <a:p>
-            <a:pPr algn="ctr" indent="0" marL="0">
+            <a:pPr marL="0" indent="0" algn="ctr">
               <a:buNone/>
             </a:pPr>
             <a:r>
@@ -5585,7 +5428,7 @@
             <a:endParaRPr lang="en-US" sz="1400" dirty="0"/>
           </a:p>
           <a:p>
-            <a:pPr algn="ctr" indent="0" marL="0">
+            <a:pPr marL="0" indent="0" algn="ctr">
               <a:buNone/>
             </a:pPr>
             <a:r>
@@ -5602,7 +5445,7 @@
       </p:sp>
       <p:sp>
         <p:nvSpPr>
-          <p:cNvPr id="25" name="Slide Number Placeholder 0"/>
+          <p:cNvPr id="28" name="Slide Number Placeholder 0"/>
           <p:cNvSpPr>
             <a:spLocks noGrp="1"/>
           </p:cNvSpPr>
@@ -5620,7 +5463,7 @@
           </a:prstGeom>
           <a:extLst>
             <a:ext uri="{C572A759-6A51-4108-AA02-DFA0A04FC94B}">
-              <ma14:wrappingTextBoxFlag xmlns:ma14="http://schemas.microsoft.com/office/mac/drawingml/2011/main" val="0"/>
+              <ma14:wrappingTextBoxFlag xmlns:ma14="http://schemas.microsoft.com/office/mac/drawingml/2011/main" xmlns="" val="0"/>
             </a:ext>
           </a:extLst>
         </p:spPr>
@@ -5638,7 +5481,7 @@
           <a:p>
             <a:pPr algn="r"/>
             <a:fld id="{F7021451-1387-4CA6-816F-3879F97B5CBC}" type="slidenum">
-              <a:rPr b="0" lang="en-US"/>
+              <a:rPr lang="en-US" b="0"/>
               <a:t>3</a:t>
             </a:fld>
             <a:endParaRPr lang="en-US"/>
@@ -5673,9 +5516,11 @@
       <p:sp>
         <p:nvSpPr>
           <p:cNvPr id="2" name="Text 0"/>
-          <p:cNvSpPr/>
+          <p:cNvSpPr>
+            <a:spLocks noGrp="1"/>
+          </p:cNvSpPr>
           <p:nvPr>
-            <p:ph idx="100" type="title" hasCustomPrompt="1"/>
+            <p:ph type="title" idx="100" hasCustomPrompt="1"/>
           </p:nvPr>
         </p:nvSpPr>
         <p:spPr>
@@ -5693,7 +5538,7 @@
           <a:bodyPr wrap="square" lIns="0" tIns="0" rIns="0" bIns="0" rtlCol="0" anchor="ctr"/>
           <a:lstStyle/>
           <a:p>
-            <a:pPr algn="l" indent="0" marL="0">
+            <a:pPr marL="0" indent="0" algn="l">
               <a:buNone/>
             </a:pPr>
             <a:r>
@@ -5751,7 +5596,7 @@
           <a:bodyPr wrap="square" lIns="0" tIns="0" rIns="0" bIns="0" rtlCol="0" anchor="ctr"/>
           <a:lstStyle/>
           <a:p>
-            <a:pPr indent="0" marL="0">
+            <a:pPr marL="0" indent="0">
               <a:spcAft>
                 <a:spcPts val="600"/>
               </a:spcAft>
@@ -5768,7 +5613,7 @@
             <a:endParaRPr lang="en-US" sz="1900" dirty="0"/>
           </a:p>
           <a:p>
-            <a:pPr indent="0" marL="0">
+            <a:pPr marL="0" indent="0">
               <a:spcAft>
                 <a:spcPts val="600"/>
               </a:spcAft>
@@ -5808,194 +5653,7 @@
       </p:sp>
       <p:pic>
         <p:nvPicPr>
-          <p:cNvPr id="6" name="Image 0" descr="Punto">    </p:cNvPr>
-          <p:cNvPicPr>
-            <a:picLocks noChangeAspect="1"/>
-          </p:cNvPicPr>
-          <p:nvPr/>
-        </p:nvPicPr>
-        <p:blipFill>
-          <a:blip r:embed="rId1"/>
-          <a:stretch>
-            <a:fillRect/>
-          </a:stretch>
-        </p:blipFill>
-        <p:spPr>
-          <a:xfrm>
-            <a:off x="713232" y="4325112"/>
-            <a:ext cx="356616" cy="356616"/>
-          </a:xfrm>
-          <a:prstGeom prst="rect">
-            <a:avLst/>
-          </a:prstGeom>
-        </p:spPr>
-      </p:pic>
-      <p:sp>
-        <p:nvSpPr>
-          <p:cNvPr id="7" name="Text 4"/>
-          <p:cNvSpPr txBox="1"/>
-          <p:nvPr/>
-        </p:nvSpPr>
-        <p:spPr>
-          <a:xfrm>
-            <a:off x="1463040" y="4160520"/>
-            <a:ext cx="4846320" cy="685800"/>
-          </a:xfrm>
-          <a:prstGeom prst="rect">
-            <a:avLst/>
-          </a:prstGeom>
-          <a:noFill/>
-          <a:ln/>
-        </p:spPr>
-        <p:txBody>
-          <a:bodyPr wrap="square" lIns="0" tIns="0" rIns="0" bIns="0" rtlCol="0" anchor="ctr"/>
-          <a:lstStyle/>
-          <a:p>
-            <a:pPr indent="0" marL="0">
-              <a:buNone/>
-            </a:pPr>
-            <a:r>
-              <a:rPr lang="en-US" sz="1700" dirty="0">
-                <a:solidFill>
-                  <a:schemeClr val="tx1"/>
-                </a:solidFill>
-              </a:rPr>
-              <a:t>Un equipo pequeño, o una sola persona en su casa, puede conseguir imágenes casi fotorrealistas.</a:t>
-            </a:r>
-            <a:endParaRPr lang="en-US" sz="1700" dirty="0"/>
-          </a:p>
-        </p:txBody>
-      </p:sp>
-      <p:sp>
-        <p:nvSpPr>
-          <p:cNvPr id="8" name="Punto"/>
-          <p:cNvSpPr/>
-          <p:nvPr/>
-        </p:nvSpPr>
-        <p:spPr>
-          <a:xfrm>
-            <a:off x="548640" y="5074920"/>
-            <a:ext cx="685800" cy="685800"/>
-          </a:xfrm>
-          <a:prstGeom prst="ellipse">
-            <a:avLst/>
-          </a:prstGeom>
-          <a:solidFill>
-            <a:schemeClr val="tx2"/>
-          </a:solidFill>
-          <a:ln/>
-        </p:spPr>
-      </p:sp>
-      <p:pic>
-        <p:nvPicPr>
-          <p:cNvPr id="9" name="Image 1" descr="Punto">    </p:cNvPr>
-          <p:cNvPicPr>
-            <a:picLocks noChangeAspect="1"/>
-          </p:cNvPicPr>
-          <p:nvPr/>
-        </p:nvPicPr>
-        <p:blipFill>
-          <a:blip r:embed="rId2"/>
-          <a:stretch>
-            <a:fillRect/>
-          </a:stretch>
-        </p:blipFill>
-        <p:spPr>
-          <a:xfrm>
-            <a:off x="713232" y="5239512"/>
-            <a:ext cx="356616" cy="356616"/>
-          </a:xfrm>
-          <a:prstGeom prst="rect">
-            <a:avLst/>
-          </a:prstGeom>
-        </p:spPr>
-      </p:pic>
-      <p:sp>
-        <p:nvSpPr>
-          <p:cNvPr id="10" name="Text 6"/>
-          <p:cNvSpPr txBox="1"/>
-          <p:nvPr/>
-        </p:nvSpPr>
-        <p:spPr>
-          <a:xfrm>
-            <a:off x="1463040" y="5074920"/>
-            <a:ext cx="4846320" cy="685800"/>
-          </a:xfrm>
-          <a:prstGeom prst="rect">
-            <a:avLst/>
-          </a:prstGeom>
-          <a:noFill/>
-          <a:ln/>
-        </p:spPr>
-        <p:txBody>
-          <a:bodyPr wrap="square" lIns="0" tIns="0" rIns="0" bIns="0" rtlCol="0" anchor="ctr"/>
-          <a:lstStyle/>
-          <a:p>
-            <a:pPr indent="0" marL="0">
-              <a:buNone/>
-            </a:pPr>
-            <a:r>
-              <a:rPr lang="en-US" sz="1700" dirty="0">
-                <a:solidFill>
-                  <a:schemeClr val="tx1"/>
-                </a:solidFill>
-              </a:rPr>
-              <a:t>Lo que antes costaba meses de trabajo especializado, ahora viene hecho.</a:t>
-            </a:r>
-            <a:endParaRPr lang="en-US" sz="1700" dirty="0"/>
-          </a:p>
-        </p:txBody>
-      </p:sp>
-      <p:sp>
-        <p:nvSpPr>
-          <p:cNvPr id="11" name="Hueco para captura"/>
-          <p:cNvSpPr/>
-          <p:nvPr/>
-        </p:nvSpPr>
-        <p:spPr>
-          <a:xfrm>
-            <a:off x="6675120" y="1463040"/>
-            <a:ext cx="4967935" cy="4343400"/>
-          </a:xfrm>
-          <a:prstGeom prst="roundRect">
-            <a:avLst>
-              <a:gd name="adj" fmla="val 2526"/>
-            </a:avLst>
-          </a:prstGeom>
-          <a:solidFill>
-            <a:schemeClr val="bg2"/>
-          </a:solidFill>
-          <a:ln w="19050">
-            <a:solidFill>
-              <a:srgbClr val="8A94A6"/>
-            </a:solidFill>
-            <a:prstDash val="dash"/>
-          </a:ln>
-        </p:spPr>
-      </p:sp>
-      <p:sp>
-        <p:nvSpPr>
-          <p:cNvPr id="12" name="Captura"/>
-          <p:cNvSpPr/>
-          <p:nvPr/>
-        </p:nvSpPr>
-        <p:spPr>
-          <a:xfrm>
-            <a:off x="8793328" y="2857500"/>
-            <a:ext cx="731520" cy="731520"/>
-          </a:xfrm>
-          <a:prstGeom prst="ellipse">
-            <a:avLst/>
-          </a:prstGeom>
-          <a:solidFill>
-            <a:schemeClr val="accent5"/>
-          </a:solidFill>
-          <a:ln/>
-        </p:spPr>
-      </p:sp>
-      <p:pic>
-        <p:nvPicPr>
-          <p:cNvPr id="13" name="Image 2" descr="Captura">    </p:cNvPr>
+          <p:cNvPr id="6" name="Image 0" descr="Punto"/>
           <p:cNvPicPr>
             <a:picLocks noChangeAspect="1"/>
           </p:cNvPicPr>
@@ -6009,6 +5667,193 @@
         </p:blipFill>
         <p:spPr>
           <a:xfrm>
+            <a:off x="713232" y="4325112"/>
+            <a:ext cx="356616" cy="356616"/>
+          </a:xfrm>
+          <a:prstGeom prst="rect">
+            <a:avLst/>
+          </a:prstGeom>
+        </p:spPr>
+      </p:pic>
+      <p:sp>
+        <p:nvSpPr>
+          <p:cNvPr id="7" name="Text 4"/>
+          <p:cNvSpPr txBox="1"/>
+          <p:nvPr/>
+        </p:nvSpPr>
+        <p:spPr>
+          <a:xfrm>
+            <a:off x="1463040" y="4160520"/>
+            <a:ext cx="4846320" cy="685800"/>
+          </a:xfrm>
+          <a:prstGeom prst="rect">
+            <a:avLst/>
+          </a:prstGeom>
+          <a:noFill/>
+          <a:ln/>
+        </p:spPr>
+        <p:txBody>
+          <a:bodyPr wrap="square" lIns="0" tIns="0" rIns="0" bIns="0" rtlCol="0" anchor="ctr"/>
+          <a:lstStyle/>
+          <a:p>
+            <a:pPr marL="0" indent="0">
+              <a:buNone/>
+            </a:pPr>
+            <a:r>
+              <a:rPr lang="en-US" sz="1700" dirty="0">
+                <a:solidFill>
+                  <a:schemeClr val="tx1"/>
+                </a:solidFill>
+              </a:rPr>
+              <a:t>Un equipo pequeño, o una sola persona en su casa, puede conseguir imágenes casi fotorrealistas.</a:t>
+            </a:r>
+            <a:endParaRPr lang="en-US" sz="1700" dirty="0"/>
+          </a:p>
+        </p:txBody>
+      </p:sp>
+      <p:sp>
+        <p:nvSpPr>
+          <p:cNvPr id="8" name="Punto"/>
+          <p:cNvSpPr/>
+          <p:nvPr/>
+        </p:nvSpPr>
+        <p:spPr>
+          <a:xfrm>
+            <a:off x="548640" y="5074920"/>
+            <a:ext cx="685800" cy="685800"/>
+          </a:xfrm>
+          <a:prstGeom prst="ellipse">
+            <a:avLst/>
+          </a:prstGeom>
+          <a:solidFill>
+            <a:schemeClr val="tx2"/>
+          </a:solidFill>
+          <a:ln/>
+        </p:spPr>
+      </p:sp>
+      <p:pic>
+        <p:nvPicPr>
+          <p:cNvPr id="9" name="Image 1" descr="Punto"/>
+          <p:cNvPicPr>
+            <a:picLocks noChangeAspect="1"/>
+          </p:cNvPicPr>
+          <p:nvPr/>
+        </p:nvPicPr>
+        <p:blipFill>
+          <a:blip r:embed="rId4"/>
+          <a:stretch>
+            <a:fillRect/>
+          </a:stretch>
+        </p:blipFill>
+        <p:spPr>
+          <a:xfrm>
+            <a:off x="713232" y="5239512"/>
+            <a:ext cx="356616" cy="356616"/>
+          </a:xfrm>
+          <a:prstGeom prst="rect">
+            <a:avLst/>
+          </a:prstGeom>
+        </p:spPr>
+      </p:pic>
+      <p:sp>
+        <p:nvSpPr>
+          <p:cNvPr id="10" name="Text 6"/>
+          <p:cNvSpPr txBox="1"/>
+          <p:nvPr/>
+        </p:nvSpPr>
+        <p:spPr>
+          <a:xfrm>
+            <a:off x="1463040" y="5074920"/>
+            <a:ext cx="4846320" cy="685800"/>
+          </a:xfrm>
+          <a:prstGeom prst="rect">
+            <a:avLst/>
+          </a:prstGeom>
+          <a:noFill/>
+          <a:ln/>
+        </p:spPr>
+        <p:txBody>
+          <a:bodyPr wrap="square" lIns="0" tIns="0" rIns="0" bIns="0" rtlCol="0" anchor="ctr"/>
+          <a:lstStyle/>
+          <a:p>
+            <a:pPr marL="0" indent="0">
+              <a:buNone/>
+            </a:pPr>
+            <a:r>
+              <a:rPr lang="en-US" sz="1700" dirty="0">
+                <a:solidFill>
+                  <a:schemeClr val="tx1"/>
+                </a:solidFill>
+              </a:rPr>
+              <a:t>Lo que antes costaba meses de trabajo especializado, ahora viene hecho.</a:t>
+            </a:r>
+            <a:endParaRPr lang="en-US" sz="1700" dirty="0"/>
+          </a:p>
+        </p:txBody>
+      </p:sp>
+      <p:sp>
+        <p:nvSpPr>
+          <p:cNvPr id="11" name="Hueco para captura"/>
+          <p:cNvSpPr/>
+          <p:nvPr/>
+        </p:nvSpPr>
+        <p:spPr>
+          <a:xfrm>
+            <a:off x="6675120" y="1463040"/>
+            <a:ext cx="4967935" cy="4343400"/>
+          </a:xfrm>
+          <a:prstGeom prst="roundRect">
+            <a:avLst>
+              <a:gd name="adj" fmla="val 2526"/>
+            </a:avLst>
+          </a:prstGeom>
+          <a:solidFill>
+            <a:schemeClr val="bg2"/>
+          </a:solidFill>
+          <a:ln w="19050">
+            <a:solidFill>
+              <a:srgbClr val="8A94A6"/>
+            </a:solidFill>
+            <a:prstDash val="dash"/>
+          </a:ln>
+        </p:spPr>
+      </p:sp>
+      <p:sp>
+        <p:nvSpPr>
+          <p:cNvPr id="12" name="Captura"/>
+          <p:cNvSpPr/>
+          <p:nvPr/>
+        </p:nvSpPr>
+        <p:spPr>
+          <a:xfrm>
+            <a:off x="8793328" y="2857500"/>
+            <a:ext cx="731520" cy="731520"/>
+          </a:xfrm>
+          <a:prstGeom prst="ellipse">
+            <a:avLst/>
+          </a:prstGeom>
+          <a:solidFill>
+            <a:schemeClr val="accent5"/>
+          </a:solidFill>
+          <a:ln/>
+        </p:spPr>
+      </p:sp>
+      <p:pic>
+        <p:nvPicPr>
+          <p:cNvPr id="13" name="Image 2" descr="Captura"/>
+          <p:cNvPicPr>
+            <a:picLocks noChangeAspect="1"/>
+          </p:cNvPicPr>
+          <p:nvPr/>
+        </p:nvPicPr>
+        <p:blipFill>
+          <a:blip r:embed="rId5"/>
+          <a:stretch>
+            <a:fillRect/>
+          </a:stretch>
+        </p:blipFill>
+        <p:spPr>
+          <a:xfrm>
             <a:off x="8968892" y="3033065"/>
             <a:ext cx="380390" cy="380390"/>
           </a:xfrm>
@@ -6017,42 +5862,6 @@
           </a:prstGeom>
         </p:spPr>
       </p:pic>
-      <p:sp>
-        <p:nvSpPr>
-          <p:cNvPr id="14" name="Text 9"/>
-          <p:cNvSpPr txBox="1"/>
-          <p:nvPr/>
-        </p:nvSpPr>
-        <p:spPr>
-          <a:xfrm>
-            <a:off x="6903720" y="3726180"/>
-            <a:ext cx="4510735" cy="1943100"/>
-          </a:xfrm>
-          <a:prstGeom prst="rect">
-            <a:avLst/>
-          </a:prstGeom>
-          <a:noFill/>
-          <a:ln/>
-        </p:spPr>
-        <p:txBody>
-          <a:bodyPr wrap="square" lIns="0" tIns="0" rIns="0" bIns="0" rtlCol="0" anchor="t"/>
-          <a:lstStyle/>
-          <a:p>
-            <a:pPr algn="ctr" indent="0" marL="0">
-              <a:buNone/>
-            </a:pPr>
-            <a:r>
-              <a:rPr lang="en-US" sz="1400" i="1" dirty="0">
-                <a:solidFill>
-                  <a:schemeClr val="tx2"/>
-                </a:solidFill>
-              </a:rPr>
-              <a:t>Captura sugerida: la demo «The Matrix Awakens» (Epic Games, 2021) o cualquier escena fotorrealista hecha con Unreal Engine 5. Enlaces en las notas.</a:t>
-            </a:r>
-            <a:endParaRPr lang="en-US" sz="1400" dirty="0"/>
-          </a:p>
-        </p:txBody>
-      </p:sp>
       <p:sp>
         <p:nvSpPr>
           <p:cNvPr id="25" name="Slide Number Placeholder 0"/>
@@ -6073,7 +5882,7 @@
           </a:prstGeom>
           <a:extLst>
             <a:ext uri="{C572A759-6A51-4108-AA02-DFA0A04FC94B}">
-              <ma14:wrappingTextBoxFlag xmlns:ma14="http://schemas.microsoft.com/office/mac/drawingml/2011/main" val="0"/>
+              <ma14:wrappingTextBoxFlag xmlns:ma14="http://schemas.microsoft.com/office/mac/drawingml/2011/main" xmlns="" val="0"/>
             </a:ext>
           </a:extLst>
         </p:spPr>
@@ -6091,13 +5900,44 @@
           <a:p>
             <a:pPr algn="r"/>
             <a:fld id="{F7021451-1387-4CA6-816F-3879F97B5CBC}" type="slidenum">
-              <a:rPr b="0" lang="en-US"/>
+              <a:rPr lang="en-US" b="0"/>
               <a:t>4</a:t>
             </a:fld>
             <a:endParaRPr lang="en-US"/>
           </a:p>
         </p:txBody>
       </p:sp>
+      <p:pic>
+        <p:nvPicPr>
+          <p:cNvPr id="15" name="Imagen 14" descr="The Matrix Awakens Set To Be Delisted July 9th - Hey Poor Player">
+            <a:extLst>
+              <a:ext uri="{FF2B5EF4-FFF2-40B4-BE49-F238E27FC236}">
+                <a16:creationId xmlns:a16="http://schemas.microsoft.com/office/drawing/2014/main" id="{3CA15AE1-7B7B-973A-CB9F-FE6BF5D3C07E}"/>
+              </a:ext>
+            </a:extLst>
+          </p:cNvPr>
+          <p:cNvPicPr>
+            <a:picLocks noChangeAspect="1"/>
+          </p:cNvPicPr>
+          <p:nvPr/>
+        </p:nvPicPr>
+        <p:blipFill>
+          <a:blip r:embed="rId6"/>
+          <a:srcRect l="20582" r="18126"/>
+          <a:stretch>
+            <a:fillRect/>
+          </a:stretch>
+        </p:blipFill>
+        <p:spPr>
+          <a:xfrm>
+            <a:off x="6675120" y="1440692"/>
+            <a:ext cx="4967935" cy="4559274"/>
+          </a:xfrm>
+          <a:prstGeom prst="rect">
+            <a:avLst/>
+          </a:prstGeom>
+        </p:spPr>
+      </p:pic>
     </p:spTree>
   </p:cSld>
   <p:clrMapOvr>
@@ -6126,9 +5966,11 @@
       <p:sp>
         <p:nvSpPr>
           <p:cNvPr id="2" name="Text 0"/>
-          <p:cNvSpPr/>
+          <p:cNvSpPr>
+            <a:spLocks noGrp="1"/>
+          </p:cNvSpPr>
           <p:nvPr>
-            <p:ph idx="100" type="title" hasCustomPrompt="1"/>
+            <p:ph type="title" idx="100" hasCustomPrompt="1"/>
           </p:nvPr>
         </p:nvSpPr>
         <p:spPr>
@@ -6146,7 +5988,7 @@
           <a:bodyPr wrap="square" lIns="0" tIns="0" rIns="0" bIns="0" rtlCol="0" anchor="ctr"/>
           <a:lstStyle/>
           <a:p>
-            <a:pPr algn="l" indent="0" marL="0">
+            <a:pPr marL="0" indent="0" algn="l">
               <a:buNone/>
             </a:pPr>
             <a:r>
@@ -6182,7 +6024,7 @@
           <a:bodyPr wrap="square" lIns="0" tIns="0" rIns="0" bIns="0" rtlCol="0" anchor="ctr"/>
           <a:lstStyle/>
           <a:p>
-            <a:pPr indent="0" marL="0">
+            <a:pPr marL="0" indent="0">
               <a:buNone/>
             </a:pPr>
             <a:r>
@@ -6698,7 +6540,7 @@
           <a:bodyPr wrap="square" lIns="0" tIns="0" rIns="0" bIns="0" rtlCol="0" anchor="ctr"/>
           <a:lstStyle/>
           <a:p>
-            <a:pPr algn="ctr" indent="0" marL="0">
+            <a:pPr marL="0" indent="0" algn="ctr">
               <a:buNone/>
             </a:pPr>
             <a:r>
@@ -6756,7 +6598,7 @@
           <a:bodyPr wrap="square" lIns="0" tIns="0" rIns="0" bIns="0" rtlCol="0" anchor="ctr"/>
           <a:lstStyle/>
           <a:p>
-            <a:pPr indent="0" marL="0">
+            <a:pPr marL="0" indent="0">
               <a:spcAft>
                 <a:spcPts val="600"/>
               </a:spcAft>
@@ -6773,7 +6615,7 @@
             <a:endParaRPr lang="en-US" sz="1900" dirty="0"/>
           </a:p>
           <a:p>
-            <a:pPr indent="0" marL="0">
+            <a:pPr marL="0" indent="0">
               <a:spcAft>
                 <a:spcPts val="600"/>
               </a:spcAft>
@@ -6834,7 +6676,7 @@
           <a:bodyPr wrap="square" lIns="0" tIns="0" rIns="0" bIns="0" rtlCol="0" anchor="ctr"/>
           <a:lstStyle/>
           <a:p>
-            <a:pPr indent="0" marL="0">
+            <a:pPr marL="0" indent="0">
               <a:spcAft>
                 <a:spcPts val="600"/>
               </a:spcAft>
@@ -6851,7 +6693,7 @@
             <a:endParaRPr lang="en-US" sz="1900" dirty="0"/>
           </a:p>
           <a:p>
-            <a:pPr indent="0" marL="0">
+            <a:pPr marL="0" indent="0">
               <a:spcAft>
                 <a:spcPts val="600"/>
               </a:spcAft>
@@ -6890,7 +6732,7 @@
           <a:bodyPr wrap="square" lIns="0" tIns="0" rIns="0" bIns="0" rtlCol="0" anchor="ctr"/>
           <a:lstStyle/>
           <a:p>
-            <a:pPr indent="0" marL="0">
+            <a:pPr marL="0" indent="0">
               <a:buNone/>
             </a:pPr>
             <a:r>
@@ -6907,7 +6749,7 @@
       </p:sp>
       <p:sp>
         <p:nvSpPr>
-          <p:cNvPr id="25" name="Slide Number Placeholder 0"/>
+          <p:cNvPr id="34" name="Slide Number Placeholder 0"/>
           <p:cNvSpPr>
             <a:spLocks noGrp="1"/>
           </p:cNvSpPr>
@@ -6925,7 +6767,7 @@
           </a:prstGeom>
           <a:extLst>
             <a:ext uri="{C572A759-6A51-4108-AA02-DFA0A04FC94B}">
-              <ma14:wrappingTextBoxFlag xmlns:ma14="http://schemas.microsoft.com/office/mac/drawingml/2011/main" val="0"/>
+              <ma14:wrappingTextBoxFlag xmlns:ma14="http://schemas.microsoft.com/office/mac/drawingml/2011/main" xmlns="" val="0"/>
             </a:ext>
           </a:extLst>
         </p:spPr>
@@ -6943,13 +6785,103 @@
           <a:p>
             <a:pPr algn="r"/>
             <a:fld id="{F7021451-1387-4CA6-816F-3879F97B5CBC}" type="slidenum">
-              <a:rPr b="0" lang="en-US"/>
+              <a:rPr lang="en-US" b="0"/>
               <a:t>5</a:t>
             </a:fld>
             <a:endParaRPr lang="en-US"/>
           </a:p>
         </p:txBody>
       </p:sp>
+      <p:pic>
+        <p:nvPicPr>
+          <p:cNvPr id="36" name="Imagen 35">
+            <a:extLst>
+              <a:ext uri="{FF2B5EF4-FFF2-40B4-BE49-F238E27FC236}">
+                <a16:creationId xmlns:a16="http://schemas.microsoft.com/office/drawing/2014/main" id="{5AE91925-1EF5-EBFF-CE64-00762E96B44D}"/>
+              </a:ext>
+            </a:extLst>
+          </p:cNvPr>
+          <p:cNvPicPr>
+            <a:picLocks noChangeAspect="1"/>
+          </p:cNvPicPr>
+          <p:nvPr/>
+        </p:nvPicPr>
+        <p:blipFill>
+          <a:blip r:embed="rId3"/>
+          <a:stretch>
+            <a:fillRect/>
+          </a:stretch>
+        </p:blipFill>
+        <p:spPr>
+          <a:xfrm>
+            <a:off x="281617" y="2057400"/>
+            <a:ext cx="1934273" cy="2179225"/>
+          </a:xfrm>
+          <a:prstGeom prst="rect">
+            <a:avLst/>
+          </a:prstGeom>
+        </p:spPr>
+      </p:pic>
+      <p:pic>
+        <p:nvPicPr>
+          <p:cNvPr id="40" name="Imagen 39">
+            <a:extLst>
+              <a:ext uri="{FF2B5EF4-FFF2-40B4-BE49-F238E27FC236}">
+                <a16:creationId xmlns:a16="http://schemas.microsoft.com/office/drawing/2014/main" id="{956F3C3A-3311-A291-2972-B4F801D42D3F}"/>
+              </a:ext>
+            </a:extLst>
+          </p:cNvPr>
+          <p:cNvPicPr>
+            <a:picLocks noChangeAspect="1"/>
+          </p:cNvPicPr>
+          <p:nvPr/>
+        </p:nvPicPr>
+        <p:blipFill>
+          <a:blip r:embed="rId4"/>
+          <a:stretch>
+            <a:fillRect/>
+          </a:stretch>
+        </p:blipFill>
+        <p:spPr>
+          <a:xfrm>
+            <a:off x="2206528" y="2069471"/>
+            <a:ext cx="1816832" cy="2180199"/>
+          </a:xfrm>
+          <a:prstGeom prst="rect">
+            <a:avLst/>
+          </a:prstGeom>
+        </p:spPr>
+      </p:pic>
+      <p:pic>
+        <p:nvPicPr>
+          <p:cNvPr id="38" name="Imagen 37">
+            <a:extLst>
+              <a:ext uri="{FF2B5EF4-FFF2-40B4-BE49-F238E27FC236}">
+                <a16:creationId xmlns:a16="http://schemas.microsoft.com/office/drawing/2014/main" id="{5BF1BD6D-1C31-4557-14E5-F14EAB4944E3}"/>
+              </a:ext>
+            </a:extLst>
+          </p:cNvPr>
+          <p:cNvPicPr>
+            <a:picLocks noChangeAspect="1"/>
+          </p:cNvPicPr>
+          <p:nvPr/>
+        </p:nvPicPr>
+        <p:blipFill>
+          <a:blip r:embed="rId5"/>
+          <a:stretch>
+            <a:fillRect/>
+          </a:stretch>
+        </p:blipFill>
+        <p:spPr>
+          <a:xfrm>
+            <a:off x="3974882" y="2057177"/>
+            <a:ext cx="1934272" cy="2178690"/>
+          </a:xfrm>
+          <a:prstGeom prst="rect">
+            <a:avLst/>
+          </a:prstGeom>
+        </p:spPr>
+      </p:pic>
     </p:spTree>
   </p:cSld>
   <p:clrMapOvr>
@@ -6978,9 +6910,11 @@
       <p:sp>
         <p:nvSpPr>
           <p:cNvPr id="2" name="Text 0"/>
-          <p:cNvSpPr/>
+          <p:cNvSpPr>
+            <a:spLocks noGrp="1"/>
+          </p:cNvSpPr>
           <p:nvPr>
-            <p:ph idx="100" type="title" hasCustomPrompt="1"/>
+            <p:ph type="title" idx="100" hasCustomPrompt="1"/>
           </p:nvPr>
         </p:nvSpPr>
         <p:spPr>
@@ -6998,7 +6932,7 @@
           <a:bodyPr wrap="square" lIns="0" tIns="0" rIns="0" bIns="0" rtlCol="0" anchor="ctr"/>
           <a:lstStyle/>
           <a:p>
-            <a:pPr algn="l" indent="0" marL="0">
+            <a:pPr marL="0" indent="0" algn="l">
               <a:buNone/>
             </a:pPr>
             <a:r>
@@ -7057,283 +6991,7 @@
       </p:sp>
       <p:pic>
         <p:nvPicPr>
-          <p:cNvPr id="5" name="Image 0" descr="Los mismos ajustes">    </p:cNvPr>
-          <p:cNvPicPr>
-            <a:picLocks noChangeAspect="1"/>
-          </p:cNvPicPr>
-          <p:nvPr/>
-        </p:nvPicPr>
-        <p:blipFill>
-          <a:blip r:embed="rId1"/>
-          <a:stretch>
-            <a:fillRect/>
-          </a:stretch>
-        </p:blipFill>
-        <p:spPr>
-          <a:xfrm>
-            <a:off x="1088136" y="2002536"/>
-            <a:ext cx="475488" cy="475488"/>
-          </a:xfrm>
-          <a:prstGeom prst="rect">
-            <a:avLst/>
-          </a:prstGeom>
-        </p:spPr>
-      </p:pic>
-      <p:sp>
-        <p:nvSpPr>
-          <p:cNvPr id="6" name="Text 3"/>
-          <p:cNvSpPr txBox="1"/>
-          <p:nvPr/>
-        </p:nvSpPr>
-        <p:spPr>
-          <a:xfrm>
-            <a:off x="868680" y="2834640"/>
-            <a:ext cx="2814218" cy="548640"/>
-          </a:xfrm>
-          <a:prstGeom prst="rect">
-            <a:avLst/>
-          </a:prstGeom>
-          <a:noFill/>
-          <a:ln/>
-        </p:spPr>
-        <p:txBody>
-          <a:bodyPr wrap="square" lIns="0" tIns="0" rIns="0" bIns="0" rtlCol="0" anchor="ctr"/>
-          <a:lstStyle/>
-          <a:p>
-            <a:pPr indent="0" marL="0">
-              <a:buNone/>
-            </a:pPr>
-            <a:r>
-              <a:rPr lang="en-US" sz="2100" b="1" dirty="0">
-                <a:solidFill>
-                  <a:schemeClr val="tx1"/>
-                </a:solidFill>
-              </a:rPr>
-              <a:t>Los mismos ajustes</a:t>
-            </a:r>
-            <a:endParaRPr lang="en-US" sz="2100" dirty="0"/>
-          </a:p>
-        </p:txBody>
-      </p:sp>
-      <p:sp>
-        <p:nvSpPr>
-          <p:cNvPr id="7" name="Text 4"/>
-          <p:cNvSpPr txBox="1"/>
-          <p:nvPr/>
-        </p:nvSpPr>
-        <p:spPr>
-          <a:xfrm>
-            <a:off x="868680" y="3383280"/>
-            <a:ext cx="2814218" cy="868680"/>
-          </a:xfrm>
-          <a:prstGeom prst="rect">
-            <a:avLst/>
-          </a:prstGeom>
-          <a:noFill/>
-          <a:ln/>
-        </p:spPr>
-        <p:txBody>
-          <a:bodyPr wrap="square" lIns="0" tIns="0" rIns="0" bIns="0" rtlCol="0" anchor="t"/>
-          <a:lstStyle/>
-          <a:p>
-            <a:pPr indent="0" marL="0">
-              <a:buNone/>
-            </a:pPr>
-            <a:r>
-              <a:rPr lang="en-US" sz="1700" dirty="0">
-                <a:solidFill>
-                  <a:schemeClr val="tx1"/>
-                </a:solidFill>
-              </a:rPr>
-              <a:t>La misma luz automática y el mismo tono «de cine», si nadie los cambia.</a:t>
-            </a:r>
-            <a:endParaRPr lang="en-US" sz="1700" dirty="0"/>
-          </a:p>
-        </p:txBody>
-      </p:sp>
-      <p:sp>
-        <p:nvSpPr>
-          <p:cNvPr id="8" name="Tarjeta"/>
-          <p:cNvSpPr/>
-          <p:nvPr/>
-        </p:nvSpPr>
-        <p:spPr>
-          <a:xfrm>
-            <a:off x="4368698" y="1508760"/>
-            <a:ext cx="3454298" cy="2834640"/>
-          </a:xfrm>
-          <a:prstGeom prst="roundRect">
-            <a:avLst>
-              <a:gd name="adj" fmla="val 4839"/>
-            </a:avLst>
-          </a:prstGeom>
-          <a:solidFill>
-            <a:schemeClr val="bg2"/>
-          </a:solidFill>
-          <a:ln/>
-        </p:spPr>
-      </p:sp>
-      <p:sp>
-        <p:nvSpPr>
-          <p:cNvPr id="9" name="Los mismos materiales"/>
-          <p:cNvSpPr/>
-          <p:nvPr/>
-        </p:nvSpPr>
-        <p:spPr>
-          <a:xfrm>
-            <a:off x="4688738" y="1783080"/>
-            <a:ext cx="914400" cy="914400"/>
-          </a:xfrm>
-          <a:prstGeom prst="ellipse">
-            <a:avLst/>
-          </a:prstGeom>
-          <a:solidFill>
-            <a:schemeClr val="tx2"/>
-          </a:solidFill>
-          <a:ln/>
-        </p:spPr>
-      </p:sp>
-      <p:pic>
-        <p:nvPicPr>
-          <p:cNvPr id="10" name="Image 1" descr="Los mismos materiales">    </p:cNvPr>
-          <p:cNvPicPr>
-            <a:picLocks noChangeAspect="1"/>
-          </p:cNvPicPr>
-          <p:nvPr/>
-        </p:nvPicPr>
-        <p:blipFill>
-          <a:blip r:embed="rId2"/>
-          <a:stretch>
-            <a:fillRect/>
-          </a:stretch>
-        </p:blipFill>
-        <p:spPr>
-          <a:xfrm>
-            <a:off x="4908194" y="2002536"/>
-            <a:ext cx="475488" cy="475488"/>
-          </a:xfrm>
-          <a:prstGeom prst="rect">
-            <a:avLst/>
-          </a:prstGeom>
-        </p:spPr>
-      </p:pic>
-      <p:sp>
-        <p:nvSpPr>
-          <p:cNvPr id="11" name="Text 7"/>
-          <p:cNvSpPr txBox="1"/>
-          <p:nvPr/>
-        </p:nvSpPr>
-        <p:spPr>
-          <a:xfrm>
-            <a:off x="4688738" y="2834640"/>
-            <a:ext cx="2814218" cy="548640"/>
-          </a:xfrm>
-          <a:prstGeom prst="rect">
-            <a:avLst/>
-          </a:prstGeom>
-          <a:noFill/>
-          <a:ln/>
-        </p:spPr>
-        <p:txBody>
-          <a:bodyPr wrap="square" lIns="0" tIns="0" rIns="0" bIns="0" rtlCol="0" anchor="ctr"/>
-          <a:lstStyle/>
-          <a:p>
-            <a:pPr indent="0" marL="0">
-              <a:buNone/>
-            </a:pPr>
-            <a:r>
-              <a:rPr lang="en-US" sz="2100" b="1" dirty="0">
-                <a:solidFill>
-                  <a:schemeClr val="tx1"/>
-                </a:solidFill>
-              </a:rPr>
-              <a:t>Los mismos materiales</a:t>
-            </a:r>
-            <a:endParaRPr lang="en-US" sz="2100" dirty="0"/>
-          </a:p>
-        </p:txBody>
-      </p:sp>
-      <p:sp>
-        <p:nvSpPr>
-          <p:cNvPr id="12" name="Text 8"/>
-          <p:cNvSpPr txBox="1"/>
-          <p:nvPr/>
-        </p:nvSpPr>
-        <p:spPr>
-          <a:xfrm>
-            <a:off x="4688738" y="3383280"/>
-            <a:ext cx="2814218" cy="868680"/>
-          </a:xfrm>
-          <a:prstGeom prst="rect">
-            <a:avLst/>
-          </a:prstGeom>
-          <a:noFill/>
-          <a:ln/>
-        </p:spPr>
-        <p:txBody>
-          <a:bodyPr wrap="square" lIns="0" tIns="0" rIns="0" bIns="0" rtlCol="0" anchor="t"/>
-          <a:lstStyle/>
-          <a:p>
-            <a:pPr indent="0" marL="0">
-              <a:buNone/>
-            </a:pPr>
-            <a:r>
-              <a:rPr lang="en-US" sz="1700" dirty="0">
-                <a:solidFill>
-                  <a:schemeClr val="tx1"/>
-                </a:solidFill>
-              </a:rPr>
-              <a:t>Las mismas rocas, árboles y texturas escaneadas, disponibles para todos.</a:t>
-            </a:r>
-            <a:endParaRPr lang="en-US" sz="1700" dirty="0"/>
-          </a:p>
-        </p:txBody>
-      </p:sp>
-      <p:sp>
-        <p:nvSpPr>
-          <p:cNvPr id="13" name="Tarjeta"/>
-          <p:cNvSpPr/>
-          <p:nvPr/>
-        </p:nvSpPr>
-        <p:spPr>
-          <a:xfrm>
-            <a:off x="8188757" y="1508760"/>
-            <a:ext cx="3454298" cy="2834640"/>
-          </a:xfrm>
-          <a:prstGeom prst="roundRect">
-            <a:avLst>
-              <a:gd name="adj" fmla="val 4839"/>
-            </a:avLst>
-          </a:prstGeom>
-          <a:solidFill>
-            <a:schemeClr val="bg2"/>
-          </a:solidFill>
-          <a:ln/>
-        </p:spPr>
-      </p:sp>
-      <p:sp>
-        <p:nvSpPr>
-          <p:cNvPr id="14" name="El atajo"/>
-          <p:cNvSpPr/>
-          <p:nvPr/>
-        </p:nvSpPr>
-        <p:spPr>
-          <a:xfrm>
-            <a:off x="8508797" y="1783080"/>
-            <a:ext cx="914400" cy="914400"/>
-          </a:xfrm>
-          <a:prstGeom prst="ellipse">
-            <a:avLst/>
-          </a:prstGeom>
-          <a:solidFill>
-            <a:schemeClr val="tx2"/>
-          </a:solidFill>
-          <a:ln/>
-        </p:spPr>
-      </p:sp>
-      <p:pic>
-        <p:nvPicPr>
-          <p:cNvPr id="15" name="Image 2" descr="El atajo">    </p:cNvPr>
+          <p:cNvPr id="5" name="Image 0" descr="Los mismos ajustes"/>
           <p:cNvPicPr>
             <a:picLocks noChangeAspect="1"/>
           </p:cNvPicPr>
@@ -7347,6 +7005,282 @@
         </p:blipFill>
         <p:spPr>
           <a:xfrm>
+            <a:off x="1088136" y="2002536"/>
+            <a:ext cx="475488" cy="475488"/>
+          </a:xfrm>
+          <a:prstGeom prst="rect">
+            <a:avLst/>
+          </a:prstGeom>
+        </p:spPr>
+      </p:pic>
+      <p:sp>
+        <p:nvSpPr>
+          <p:cNvPr id="6" name="Text 3"/>
+          <p:cNvSpPr txBox="1"/>
+          <p:nvPr/>
+        </p:nvSpPr>
+        <p:spPr>
+          <a:xfrm>
+            <a:off x="868680" y="2834640"/>
+            <a:ext cx="2814218" cy="548640"/>
+          </a:xfrm>
+          <a:prstGeom prst="rect">
+            <a:avLst/>
+          </a:prstGeom>
+          <a:noFill/>
+          <a:ln/>
+        </p:spPr>
+        <p:txBody>
+          <a:bodyPr wrap="square" lIns="0" tIns="0" rIns="0" bIns="0" rtlCol="0" anchor="ctr"/>
+          <a:lstStyle/>
+          <a:p>
+            <a:pPr marL="0" indent="0">
+              <a:buNone/>
+            </a:pPr>
+            <a:r>
+              <a:rPr lang="en-US" sz="2100" b="1" dirty="0">
+                <a:solidFill>
+                  <a:schemeClr val="tx1"/>
+                </a:solidFill>
+              </a:rPr>
+              <a:t>Los mismos ajustes</a:t>
+            </a:r>
+            <a:endParaRPr lang="en-US" sz="2100" dirty="0"/>
+          </a:p>
+        </p:txBody>
+      </p:sp>
+      <p:sp>
+        <p:nvSpPr>
+          <p:cNvPr id="7" name="Text 4"/>
+          <p:cNvSpPr txBox="1"/>
+          <p:nvPr/>
+        </p:nvSpPr>
+        <p:spPr>
+          <a:xfrm>
+            <a:off x="868680" y="3383280"/>
+            <a:ext cx="2814218" cy="868680"/>
+          </a:xfrm>
+          <a:prstGeom prst="rect">
+            <a:avLst/>
+          </a:prstGeom>
+          <a:noFill/>
+          <a:ln/>
+        </p:spPr>
+        <p:txBody>
+          <a:bodyPr wrap="square" lIns="0" tIns="0" rIns="0" bIns="0" rtlCol="0" anchor="t"/>
+          <a:lstStyle/>
+          <a:p>
+            <a:pPr marL="0" indent="0">
+              <a:buNone/>
+            </a:pPr>
+            <a:r>
+              <a:rPr lang="en-US" sz="1700" dirty="0">
+                <a:solidFill>
+                  <a:schemeClr val="tx1"/>
+                </a:solidFill>
+              </a:rPr>
+              <a:t>La misma luz automática y el mismo tono «de cine», si nadie los cambia.</a:t>
+            </a:r>
+            <a:endParaRPr lang="en-US" sz="1700" dirty="0"/>
+          </a:p>
+        </p:txBody>
+      </p:sp>
+      <p:sp>
+        <p:nvSpPr>
+          <p:cNvPr id="8" name="Tarjeta"/>
+          <p:cNvSpPr/>
+          <p:nvPr/>
+        </p:nvSpPr>
+        <p:spPr>
+          <a:xfrm>
+            <a:off x="4368698" y="1508760"/>
+            <a:ext cx="3454298" cy="2834640"/>
+          </a:xfrm>
+          <a:prstGeom prst="roundRect">
+            <a:avLst>
+              <a:gd name="adj" fmla="val 4839"/>
+            </a:avLst>
+          </a:prstGeom>
+          <a:solidFill>
+            <a:schemeClr val="bg2"/>
+          </a:solidFill>
+          <a:ln/>
+        </p:spPr>
+      </p:sp>
+      <p:sp>
+        <p:nvSpPr>
+          <p:cNvPr id="9" name="Los mismos materiales"/>
+          <p:cNvSpPr/>
+          <p:nvPr/>
+        </p:nvSpPr>
+        <p:spPr>
+          <a:xfrm>
+            <a:off x="4688738" y="1783080"/>
+            <a:ext cx="914400" cy="914400"/>
+          </a:xfrm>
+          <a:prstGeom prst="ellipse">
+            <a:avLst/>
+          </a:prstGeom>
+          <a:solidFill>
+            <a:schemeClr val="tx2"/>
+          </a:solidFill>
+          <a:ln/>
+        </p:spPr>
+      </p:sp>
+      <p:pic>
+        <p:nvPicPr>
+          <p:cNvPr id="10" name="Image 1" descr="Los mismos materiales"/>
+          <p:cNvPicPr>
+            <a:picLocks noChangeAspect="1"/>
+          </p:cNvPicPr>
+          <p:nvPr/>
+        </p:nvPicPr>
+        <p:blipFill>
+          <a:blip r:embed="rId4"/>
+          <a:stretch>
+            <a:fillRect/>
+          </a:stretch>
+        </p:blipFill>
+        <p:spPr>
+          <a:xfrm>
+            <a:off x="4908194" y="2002536"/>
+            <a:ext cx="475488" cy="475488"/>
+          </a:xfrm>
+          <a:prstGeom prst="rect">
+            <a:avLst/>
+          </a:prstGeom>
+        </p:spPr>
+      </p:pic>
+      <p:sp>
+        <p:nvSpPr>
+          <p:cNvPr id="11" name="Text 7"/>
+          <p:cNvSpPr txBox="1"/>
+          <p:nvPr/>
+        </p:nvSpPr>
+        <p:spPr>
+          <a:xfrm>
+            <a:off x="4688738" y="2834640"/>
+            <a:ext cx="2814218" cy="548640"/>
+          </a:xfrm>
+          <a:prstGeom prst="rect">
+            <a:avLst/>
+          </a:prstGeom>
+          <a:noFill/>
+          <a:ln/>
+        </p:spPr>
+        <p:txBody>
+          <a:bodyPr wrap="square" lIns="0" tIns="0" rIns="0" bIns="0" rtlCol="0" anchor="ctr"/>
+          <a:lstStyle/>
+          <a:p>
+            <a:pPr marL="0" indent="0">
+              <a:buNone/>
+            </a:pPr>
+            <a:r>
+              <a:rPr lang="en-US" sz="2100" b="1" dirty="0">
+                <a:solidFill>
+                  <a:schemeClr val="tx1"/>
+                </a:solidFill>
+              </a:rPr>
+              <a:t>Los mismos materiales</a:t>
+            </a:r>
+            <a:endParaRPr lang="en-US" sz="2100" dirty="0"/>
+          </a:p>
+        </p:txBody>
+      </p:sp>
+      <p:sp>
+        <p:nvSpPr>
+          <p:cNvPr id="12" name="Text 8"/>
+          <p:cNvSpPr txBox="1"/>
+          <p:nvPr/>
+        </p:nvSpPr>
+        <p:spPr>
+          <a:xfrm>
+            <a:off x="4688738" y="3383280"/>
+            <a:ext cx="2814218" cy="868680"/>
+          </a:xfrm>
+          <a:prstGeom prst="rect">
+            <a:avLst/>
+          </a:prstGeom>
+          <a:noFill/>
+          <a:ln/>
+        </p:spPr>
+        <p:txBody>
+          <a:bodyPr wrap="square" lIns="0" tIns="0" rIns="0" bIns="0" rtlCol="0" anchor="t"/>
+          <a:lstStyle/>
+          <a:p>
+            <a:pPr marL="0" indent="0">
+              <a:buNone/>
+            </a:pPr>
+            <a:r>
+              <a:rPr lang="en-US" sz="1700" dirty="0">
+                <a:solidFill>
+                  <a:schemeClr val="tx1"/>
+                </a:solidFill>
+              </a:rPr>
+              <a:t>Las mismas rocas, árboles y texturas escaneadas, disponibles para todos.</a:t>
+            </a:r>
+            <a:endParaRPr lang="en-US" sz="1700" dirty="0"/>
+          </a:p>
+        </p:txBody>
+      </p:sp>
+      <p:sp>
+        <p:nvSpPr>
+          <p:cNvPr id="13" name="Tarjeta"/>
+          <p:cNvSpPr/>
+          <p:nvPr/>
+        </p:nvSpPr>
+        <p:spPr>
+          <a:xfrm>
+            <a:off x="8188757" y="1508760"/>
+            <a:ext cx="3454298" cy="2834640"/>
+          </a:xfrm>
+          <a:prstGeom prst="roundRect">
+            <a:avLst>
+              <a:gd name="adj" fmla="val 4839"/>
+            </a:avLst>
+          </a:prstGeom>
+          <a:solidFill>
+            <a:schemeClr val="bg2"/>
+          </a:solidFill>
+          <a:ln/>
+        </p:spPr>
+      </p:sp>
+      <p:sp>
+        <p:nvSpPr>
+          <p:cNvPr id="14" name="El atajo"/>
+          <p:cNvSpPr/>
+          <p:nvPr/>
+        </p:nvSpPr>
+        <p:spPr>
+          <a:xfrm>
+            <a:off x="8508797" y="1783080"/>
+            <a:ext cx="914400" cy="914400"/>
+          </a:xfrm>
+          <a:prstGeom prst="ellipse">
+            <a:avLst/>
+          </a:prstGeom>
+          <a:solidFill>
+            <a:schemeClr val="tx2"/>
+          </a:solidFill>
+          <a:ln/>
+        </p:spPr>
+      </p:sp>
+      <p:pic>
+        <p:nvPicPr>
+          <p:cNvPr id="15" name="Image 2" descr="El atajo"/>
+          <p:cNvPicPr>
+            <a:picLocks noChangeAspect="1"/>
+          </p:cNvPicPr>
+          <p:nvPr/>
+        </p:nvPicPr>
+        <p:blipFill>
+          <a:blip r:embed="rId5"/>
+          <a:stretch>
+            <a:fillRect/>
+          </a:stretch>
+        </p:blipFill>
+        <p:spPr>
+          <a:xfrm>
             <a:off x="8728253" y="2002536"/>
             <a:ext cx="475488" cy="475488"/>
           </a:xfrm>
@@ -7376,7 +7310,7 @@
           <a:bodyPr wrap="square" lIns="0" tIns="0" rIns="0" bIns="0" rtlCol="0" anchor="ctr"/>
           <a:lstStyle/>
           <a:p>
-            <a:pPr indent="0" marL="0">
+            <a:pPr marL="0" indent="0">
               <a:buNone/>
             </a:pPr>
             <a:r>
@@ -7412,7 +7346,7 @@
           <a:bodyPr wrap="square" lIns="0" tIns="0" rIns="0" bIns="0" rtlCol="0" anchor="t"/>
           <a:lstStyle/>
           <a:p>
-            <a:pPr indent="0" marL="0">
+            <a:pPr marL="0" indent="0">
               <a:buNone/>
             </a:pPr>
             <a:r>
@@ -7470,7 +7404,7 @@
           <a:bodyPr wrap="square" lIns="0" tIns="0" rIns="0" bIns="0" rtlCol="0" anchor="ctr"/>
           <a:lstStyle/>
           <a:p>
-            <a:pPr indent="0" marL="0">
+            <a:pPr marL="0" indent="0">
               <a:spcAft>
                 <a:spcPts val="600"/>
               </a:spcAft>
@@ -7487,7 +7421,7 @@
             <a:endParaRPr lang="en-US" sz="1900" dirty="0"/>
           </a:p>
           <a:p>
-            <a:pPr indent="0" marL="0">
+            <a:pPr marL="0" indent="0">
               <a:spcAft>
                 <a:spcPts val="600"/>
               </a:spcAft>
@@ -7525,7 +7459,7 @@
           </a:prstGeom>
           <a:extLst>
             <a:ext uri="{C572A759-6A51-4108-AA02-DFA0A04FC94B}">
-              <ma14:wrappingTextBoxFlag xmlns:ma14="http://schemas.microsoft.com/office/mac/drawingml/2011/main" val="0"/>
+              <ma14:wrappingTextBoxFlag xmlns:ma14="http://schemas.microsoft.com/office/mac/drawingml/2011/main" xmlns="" val="0"/>
             </a:ext>
           </a:extLst>
         </p:spPr>
@@ -7543,7 +7477,7 @@
           <a:p>
             <a:pPr algn="r"/>
             <a:fld id="{F7021451-1387-4CA6-816F-3879F97B5CBC}" type="slidenum">
-              <a:rPr b="0" lang="en-US"/>
+              <a:rPr lang="en-US" b="0"/>
               <a:t>6</a:t>
             </a:fld>
             <a:endParaRPr lang="en-US"/>
@@ -7578,9 +7512,11 @@
       <p:sp>
         <p:nvSpPr>
           <p:cNvPr id="2" name="Text 0"/>
-          <p:cNvSpPr/>
+          <p:cNvSpPr>
+            <a:spLocks noGrp="1"/>
+          </p:cNvSpPr>
           <p:nvPr>
-            <p:ph idx="100" type="title" hasCustomPrompt="1"/>
+            <p:ph type="title" idx="100" hasCustomPrompt="1"/>
           </p:nvPr>
         </p:nvSpPr>
         <p:spPr>
@@ -7598,7 +7534,7 @@
           <a:bodyPr wrap="square" lIns="0" tIns="0" rIns="0" bIns="0" rtlCol="0" anchor="ctr"/>
           <a:lstStyle/>
           <a:p>
-            <a:pPr algn="l" indent="0" marL="0">
+            <a:pPr marL="0" indent="0" algn="l">
               <a:buNone/>
             </a:pPr>
             <a:r>
@@ -7634,7 +7570,7 @@
           <a:bodyPr wrap="square" lIns="0" tIns="0" rIns="0" bIns="0" rtlCol="0" anchor="ctr"/>
           <a:lstStyle/>
           <a:p>
-            <a:pPr indent="0" marL="0">
+            <a:pPr marL="0" indent="0">
               <a:buNone/>
             </a:pPr>
             <a:r>
@@ -8150,7 +8086,7 @@
           <a:bodyPr wrap="square" lIns="0" tIns="0" rIns="0" bIns="0" rtlCol="0" anchor="ctr"/>
           <a:lstStyle/>
           <a:p>
-            <a:pPr indent="0" marL="0">
+            <a:pPr marL="0" indent="0">
               <a:buNone/>
             </a:pPr>
             <a:r>
@@ -8186,7 +8122,7 @@
           <a:bodyPr wrap="square" lIns="0" tIns="0" rIns="0" bIns="0" rtlCol="0" anchor="ctr"/>
           <a:lstStyle/>
           <a:p>
-            <a:pPr indent="0" marL="0">
+            <a:pPr marL="0" indent="0">
               <a:buNone/>
             </a:pPr>
             <a:r>
@@ -8222,7 +8158,7 @@
           <a:bodyPr wrap="square" lIns="0" tIns="0" rIns="0" bIns="0" rtlCol="0" anchor="ctr"/>
           <a:lstStyle/>
           <a:p>
-            <a:pPr indent="0" marL="0">
+            <a:pPr marL="0" indent="0">
               <a:buNone/>
             </a:pPr>
             <a:r>
@@ -8258,7 +8194,7 @@
           <a:bodyPr wrap="square" lIns="0" tIns="0" rIns="0" bIns="0" rtlCol="0" anchor="ctr"/>
           <a:lstStyle/>
           <a:p>
-            <a:pPr indent="0" marL="0">
+            <a:pPr marL="0" indent="0">
               <a:buNone/>
             </a:pPr>
             <a:r>
@@ -8294,7 +8230,7 @@
           <a:bodyPr wrap="square" lIns="0" tIns="0" rIns="0" bIns="0" rtlCol="0" anchor="ctr"/>
           <a:lstStyle/>
           <a:p>
-            <a:pPr indent="0" marL="0">
+            <a:pPr marL="0" indent="0">
               <a:buNone/>
             </a:pPr>
             <a:r>
@@ -8330,7 +8266,7 @@
           <a:bodyPr wrap="square" lIns="0" tIns="0" rIns="0" bIns="0" rtlCol="0" anchor="ctr"/>
           <a:lstStyle/>
           <a:p>
-            <a:pPr indent="0" marL="0">
+            <a:pPr marL="0" indent="0">
               <a:buNone/>
             </a:pPr>
             <a:r>
@@ -8367,14 +8303,14 @@
       </p:sp>
       <p:pic>
         <p:nvPicPr>
-          <p:cNvPr id="35" name="Image 0" descr="Premio">    </p:cNvPr>
+          <p:cNvPr id="35" name="Image 0" descr="Premio"/>
           <p:cNvPicPr>
             <a:picLocks noChangeAspect="1"/>
           </p:cNvPicPr>
           <p:nvPr/>
         </p:nvPicPr>
         <p:blipFill>
-          <a:blip r:embed="rId1"/>
+          <a:blip r:embed="rId3"/>
           <a:stretch>
             <a:fillRect/>
           </a:stretch>
@@ -8410,7 +8346,7 @@
           <a:bodyPr wrap="square" lIns="0" tIns="0" rIns="0" bIns="0" rtlCol="0" anchor="ctr"/>
           <a:lstStyle/>
           <a:p>
-            <a:pPr indent="0" marL="0">
+            <a:pPr marL="0" indent="0">
               <a:buNone/>
             </a:pPr>
             <a:r>
@@ -8474,14 +8410,14 @@
       </p:sp>
       <p:pic>
         <p:nvPicPr>
-          <p:cNvPr id="39" name="Image 1" descr="Captura">    </p:cNvPr>
+          <p:cNvPr id="39" name="Image 1" descr="Captura"/>
           <p:cNvPicPr>
             <a:picLocks noChangeAspect="1"/>
           </p:cNvPicPr>
           <p:nvPr/>
         </p:nvPicPr>
         <p:blipFill>
-          <a:blip r:embed="rId2"/>
+          <a:blip r:embed="rId4"/>
           <a:stretch>
             <a:fillRect/>
           </a:stretch>
@@ -8498,43 +8434,7 @@
       </p:pic>
       <p:sp>
         <p:nvSpPr>
-          <p:cNvPr id="40" name="Text 36"/>
-          <p:cNvSpPr txBox="1"/>
-          <p:nvPr/>
-        </p:nvSpPr>
-        <p:spPr>
-          <a:xfrm>
-            <a:off x="8092440" y="4206240"/>
-            <a:ext cx="3322015" cy="1828800"/>
-          </a:xfrm>
-          <a:prstGeom prst="rect">
-            <a:avLst/>
-          </a:prstGeom>
-          <a:noFill/>
-          <a:ln/>
-        </p:spPr>
-        <p:txBody>
-          <a:bodyPr wrap="square" lIns="0" tIns="0" rIns="0" bIns="0" rtlCol="0" anchor="t"/>
-          <a:lstStyle/>
-          <a:p>
-            <a:pPr algn="ctr" indent="0" marL="0">
-              <a:buNone/>
-            </a:pPr>
-            <a:r>
-              <a:rPr lang="en-US" sz="1400" i="1" dirty="0">
-                <a:solidFill>
-                  <a:schemeClr val="tx2"/>
-                </a:solidFill>
-              </a:rPr>
-              <a:t>Captura sugerida: una escena de Clair Obscur: Expedition 33 (kit de prensa oficial o página del juego). Enlaces en las notas.</a:t>
-            </a:r>
-            <a:endParaRPr lang="en-US" sz="1400" dirty="0"/>
-          </a:p>
-        </p:txBody>
-      </p:sp>
-      <p:sp>
-        <p:nvSpPr>
-          <p:cNvPr id="25" name="Slide Number Placeholder 0"/>
+          <p:cNvPr id="41" name="Slide Number Placeholder 0"/>
           <p:cNvSpPr>
             <a:spLocks noGrp="1"/>
           </p:cNvSpPr>
@@ -8552,7 +8452,7 @@
           </a:prstGeom>
           <a:extLst>
             <a:ext uri="{C572A759-6A51-4108-AA02-DFA0A04FC94B}">
-              <ma14:wrappingTextBoxFlag xmlns:ma14="http://schemas.microsoft.com/office/mac/drawingml/2011/main" val="0"/>
+              <ma14:wrappingTextBoxFlag xmlns:ma14="http://schemas.microsoft.com/office/mac/drawingml/2011/main" xmlns="" val="0"/>
             </a:ext>
           </a:extLst>
         </p:spPr>
@@ -8570,13 +8470,44 @@
           <a:p>
             <a:pPr algn="r"/>
             <a:fld id="{F7021451-1387-4CA6-816F-3879F97B5CBC}" type="slidenum">
-              <a:rPr b="0" lang="en-US"/>
+              <a:rPr lang="en-US" b="0"/>
               <a:t>7</a:t>
             </a:fld>
             <a:endParaRPr lang="en-US"/>
           </a:p>
         </p:txBody>
       </p:sp>
+      <p:pic>
+        <p:nvPicPr>
+          <p:cNvPr id="42" name="Imagen 41" descr="Análisis de Clair Obscur: Expedition 33: La mezcla imposible entre Final  Fantasy y Sekiro es también un RPG imprescindible - Reseñas 3DJuegos">
+            <a:extLst>
+              <a:ext uri="{FF2B5EF4-FFF2-40B4-BE49-F238E27FC236}">
+                <a16:creationId xmlns:a16="http://schemas.microsoft.com/office/drawing/2014/main" id="{BACBAE2E-4847-1591-83F7-8F9C0B4AB28E}"/>
+              </a:ext>
+            </a:extLst>
+          </p:cNvPr>
+          <p:cNvPicPr>
+            <a:picLocks noChangeAspect="1"/>
+          </p:cNvPicPr>
+          <p:nvPr/>
+        </p:nvPicPr>
+        <p:blipFill>
+          <a:blip r:embed="rId5"/>
+          <a:srcRect l="17515" r="10964"/>
+          <a:stretch>
+            <a:fillRect/>
+          </a:stretch>
+        </p:blipFill>
+        <p:spPr>
+          <a:xfrm>
+            <a:off x="7796085" y="1965960"/>
+            <a:ext cx="4069994" cy="4267962"/>
+          </a:xfrm>
+          <a:prstGeom prst="rect">
+            <a:avLst/>
+          </a:prstGeom>
+        </p:spPr>
+      </p:pic>
     </p:spTree>
   </p:cSld>
   <p:clrMapOvr>
@@ -8605,9 +8536,11 @@
       <p:sp>
         <p:nvSpPr>
           <p:cNvPr id="2" name="Text 0"/>
-          <p:cNvSpPr/>
+          <p:cNvSpPr>
+            <a:spLocks noGrp="1"/>
+          </p:cNvSpPr>
           <p:nvPr>
-            <p:ph idx="100" type="body" hasCustomPrompt="1"/>
+            <p:ph type="body" idx="100" hasCustomPrompt="1"/>
           </p:nvPr>
         </p:nvSpPr>
         <p:spPr>
@@ -8625,7 +8558,7 @@
           <a:bodyPr wrap="square" lIns="0" tIns="0" rIns="0" bIns="0" rtlCol="0" anchor="ctr"/>
           <a:lstStyle/>
           <a:p>
-            <a:pPr indent="0" marL="0">
+            <a:pPr marL="0" indent="0">
               <a:buNone/>
             </a:pPr>
             <a:r>
@@ -8639,7 +8572,7 @@
             <a:endParaRPr lang="en-US" sz="3400" dirty="0"/>
           </a:p>
           <a:p>
-            <a:pPr indent="0" marL="0">
+            <a:pPr marL="0" indent="0">
               <a:buNone/>
             </a:pPr>
             <a:r>
@@ -8674,7 +8607,7 @@
           </a:prstGeom>
           <a:extLst>
             <a:ext uri="{C572A759-6A51-4108-AA02-DFA0A04FC94B}">
-              <ma14:wrappingTextBoxFlag xmlns:ma14="http://schemas.microsoft.com/office/mac/drawingml/2011/main" val="0"/>
+              <ma14:wrappingTextBoxFlag xmlns:ma14="http://schemas.microsoft.com/office/mac/drawingml/2011/main" xmlns="" val="0"/>
             </a:ext>
           </a:extLst>
         </p:spPr>
@@ -8692,7 +8625,7 @@
           <a:p>
             <a:pPr algn="r"/>
             <a:fld id="{F7021451-1387-4CA6-816F-3879F97B5CBC}" type="slidenum">
-              <a:rPr b="0" lang="en-US"/>
+              <a:rPr lang="en-US" b="0"/>
               <a:t>8</a:t>
             </a:fld>
             <a:endParaRPr lang="en-US"/>
@@ -8727,9 +8660,11 @@
       <p:sp>
         <p:nvSpPr>
           <p:cNvPr id="2" name="Text 0"/>
-          <p:cNvSpPr/>
+          <p:cNvSpPr>
+            <a:spLocks noGrp="1"/>
+          </p:cNvSpPr>
           <p:nvPr>
-            <p:ph idx="100" type="title" hasCustomPrompt="1"/>
+            <p:ph type="title" idx="100" hasCustomPrompt="1"/>
           </p:nvPr>
         </p:nvSpPr>
         <p:spPr>
@@ -8747,7 +8682,7 @@
           <a:bodyPr wrap="square" lIns="0" tIns="0" rIns="0" bIns="0" rtlCol="0" anchor="ctr"/>
           <a:lstStyle/>
           <a:p>
-            <a:pPr algn="l" indent="0" marL="0">
+            <a:pPr marL="0" indent="0" algn="l">
               <a:buNone/>
             </a:pPr>
             <a:r>
@@ -8784,14 +8719,14 @@
       </p:sp>
       <p:pic>
         <p:nvPicPr>
-          <p:cNvPr id="4" name="Image 0" descr="Experimento">    </p:cNvPr>
+          <p:cNvPr id="4" name="Image 0" descr="Experimento"/>
           <p:cNvPicPr>
             <a:picLocks noChangeAspect="1"/>
           </p:cNvPicPr>
           <p:nvPr/>
         </p:nvPicPr>
         <p:blipFill>
-          <a:blip r:embed="rId1"/>
+          <a:blip r:embed="rId3"/>
           <a:stretch>
             <a:fillRect/>
           </a:stretch>
@@ -8827,7 +8762,7 @@
           <a:bodyPr wrap="square" lIns="0" tIns="0" rIns="0" bIns="0" rtlCol="0" anchor="ctr"/>
           <a:lstStyle/>
           <a:p>
-            <a:pPr indent="0" marL="0">
+            <a:pPr marL="0" indent="0">
               <a:buNone/>
             </a:pPr>
             <a:r>
@@ -8885,7 +8820,7 @@
           <a:bodyPr wrap="square" lIns="0" tIns="0" rIns="0" bIns="0" rtlCol="0" anchor="ctr"/>
           <a:lstStyle/>
           <a:p>
-            <a:pPr algn="ctr" indent="0" marL="0">
+            <a:pPr marL="0" indent="0" algn="ctr">
               <a:buNone/>
             </a:pPr>
             <a:r>
@@ -8921,7 +8856,7 @@
           <a:bodyPr wrap="square" lIns="0" tIns="0" rIns="0" bIns="0" rtlCol="0" anchor="t"/>
           <a:lstStyle/>
           <a:p>
-            <a:pPr algn="ctr" indent="0" marL="0">
+            <a:pPr marL="0" indent="0" algn="ctr">
               <a:buNone/>
             </a:pPr>
             <a:r>
@@ -8935,7 +8870,7 @@
             <a:endParaRPr lang="en-US" sz="2000" dirty="0"/>
           </a:p>
           <a:p>
-            <a:pPr algn="ctr" indent="0" marL="0">
+            <a:pPr marL="0" indent="0" algn="ctr">
               <a:buNone/>
             </a:pPr>
             <a:r>
@@ -8993,7 +8928,7 @@
           <a:bodyPr wrap="square" lIns="0" tIns="0" rIns="0" bIns="0" rtlCol="0" anchor="ctr"/>
           <a:lstStyle/>
           <a:p>
-            <a:pPr algn="ctr" indent="0" marL="0">
+            <a:pPr marL="0" indent="0" algn="ctr">
               <a:buNone/>
             </a:pPr>
             <a:r>
@@ -9029,7 +8964,7 @@
           <a:bodyPr wrap="square" lIns="0" tIns="0" rIns="0" bIns="0" rtlCol="0" anchor="t"/>
           <a:lstStyle/>
           <a:p>
-            <a:pPr algn="ctr" indent="0" marL="0">
+            <a:pPr marL="0" indent="0" algn="ctr">
               <a:buNone/>
             </a:pPr>
             <a:r>
@@ -9043,7 +8978,7 @@
             <a:endParaRPr lang="en-US" sz="2000" dirty="0"/>
           </a:p>
           <a:p>
-            <a:pPr algn="ctr" indent="0" marL="0">
+            <a:pPr marL="0" indent="0" algn="ctr">
               <a:buNone/>
             </a:pPr>
             <a:r>
@@ -9101,7 +9036,7 @@
           <a:bodyPr wrap="square" lIns="0" tIns="0" rIns="0" bIns="0" rtlCol="0" anchor="ctr"/>
           <a:lstStyle/>
           <a:p>
-            <a:pPr algn="ctr" indent="0" marL="0">
+            <a:pPr marL="0" indent="0" algn="ctr">
               <a:buNone/>
             </a:pPr>
             <a:r>
@@ -9137,7 +9072,7 @@
           <a:bodyPr wrap="square" lIns="0" tIns="0" rIns="0" bIns="0" rtlCol="0" anchor="t"/>
           <a:lstStyle/>
           <a:p>
-            <a:pPr algn="ctr" indent="0" marL="0">
+            <a:pPr marL="0" indent="0" algn="ctr">
               <a:buNone/>
             </a:pPr>
             <a:r>
@@ -9151,7 +9086,7 @@
             <a:endParaRPr lang="en-US" sz="2000" dirty="0"/>
           </a:p>
           <a:p>
-            <a:pPr algn="ctr" indent="0" marL="0">
+            <a:pPr marL="0" indent="0" algn="ctr">
               <a:buNone/>
             </a:pPr>
             <a:r>
@@ -9187,7 +9122,7 @@
           <a:bodyPr wrap="square" lIns="0" tIns="0" rIns="0" bIns="0" rtlCol="0" anchor="ctr"/>
           <a:lstStyle/>
           <a:p>
-            <a:pPr indent="0" marL="0">
+            <a:pPr marL="0" indent="0">
               <a:buNone/>
             </a:pPr>
             <a:r>
@@ -9222,7 +9157,7 @@
           </a:prstGeom>
           <a:extLst>
             <a:ext uri="{C572A759-6A51-4108-AA02-DFA0A04FC94B}">
-              <ma14:wrappingTextBoxFlag xmlns:ma14="http://schemas.microsoft.com/office/mac/drawingml/2011/main" val="0"/>
+              <ma14:wrappingTextBoxFlag xmlns:ma14="http://schemas.microsoft.com/office/mac/drawingml/2011/main" xmlns="" val="0"/>
             </a:ext>
           </a:extLst>
         </p:spPr>
@@ -9240,7 +9175,7 @@
           <a:p>
             <a:pPr algn="r"/>
             <a:fld id="{F7021451-1387-4CA6-816F-3879F97B5CBC}" type="slidenum">
-              <a:rPr b="0" lang="en-US"/>
+              <a:rPr lang="en-US" b="0"/>
               <a:t>9</a:t>
             </a:fld>
             <a:endParaRPr lang="en-US"/>
@@ -9548,4 +9483,299 @@
     </a:ext>
   </a:extLst>
 </a:theme>
+</file>
+
+<file path=ppt/theme/theme2.xml><?xml version="1.0" encoding="utf-8"?>
+<a:theme xmlns:a="http://schemas.openxmlformats.org/drawingml/2006/main" name="Tema de Office">
+  <a:themeElements>
+    <a:clrScheme name="Office">
+      <a:dk1>
+        <a:sysClr val="windowText" lastClr="000000"/>
+      </a:dk1>
+      <a:lt1>
+        <a:sysClr val="window" lastClr="FFFFFF"/>
+      </a:lt1>
+      <a:dk2>
+        <a:srgbClr val="44546A"/>
+      </a:dk2>
+      <a:lt2>
+        <a:srgbClr val="E7E6E6"/>
+      </a:lt2>
+      <a:accent1>
+        <a:srgbClr val="4472C4"/>
+      </a:accent1>
+      <a:accent2>
+        <a:srgbClr val="ED7D31"/>
+      </a:accent2>
+      <a:accent3>
+        <a:srgbClr val="A5A5A5"/>
+      </a:accent3>
+      <a:accent4>
+        <a:srgbClr val="FFC000"/>
+      </a:accent4>
+      <a:accent5>
+        <a:srgbClr val="5B9BD5"/>
+      </a:accent5>
+      <a:accent6>
+        <a:srgbClr val="70AD47"/>
+      </a:accent6>
+      <a:hlink>
+        <a:srgbClr val="0563C1"/>
+      </a:hlink>
+      <a:folHlink>
+        <a:srgbClr val="954F72"/>
+      </a:folHlink>
+    </a:clrScheme>
+    <a:fontScheme name="Office">
+      <a:majorFont>
+        <a:latin typeface="Calibri Light" panose="020F0302020204030204"/>
+        <a:ea typeface=""/>
+        <a:cs typeface=""/>
+        <a:font script="Jpan" typeface="游ゴシック Light"/>
+        <a:font script="Hang" typeface="맑은 고딕"/>
+        <a:font script="Hans" typeface="等线 Light"/>
+        <a:font script="Hant" typeface="新細明體"/>
+        <a:font script="Arab" typeface="Times New Roman"/>
+        <a:font script="Hebr" typeface="Times New Roman"/>
+        <a:font script="Thai" typeface="Angsana New"/>
+        <a:font script="Ethi" typeface="Nyala"/>
+        <a:font script="Beng" typeface="Vrinda"/>
+        <a:font script="Gujr" typeface="Shruti"/>
+        <a:font script="Khmr" typeface="MoolBoran"/>
+        <a:font script="Knda" typeface="Tunga"/>
+        <a:font script="Guru" typeface="Raavi"/>
+        <a:font script="Cans" typeface="Euphemia"/>
+        <a:font script="Cher" typeface="Plantagenet Cherokee"/>
+        <a:font script="Yiii" typeface="Microsoft Yi Baiti"/>
+        <a:font script="Tibt" typeface="Microsoft Himalaya"/>
+        <a:font script="Thaa" typeface="MV Boli"/>
+        <a:font script="Deva" typeface="Mangal"/>
+        <a:font script="Telu" typeface="Gautami"/>
+        <a:font script="Taml" typeface="Latha"/>
+        <a:font script="Syrc" typeface="Estrangelo Edessa"/>
+        <a:font script="Orya" typeface="Kalinga"/>
+        <a:font script="Mlym" typeface="Kartika"/>
+        <a:font script="Laoo" typeface="DokChampa"/>
+        <a:font script="Sinh" typeface="Iskoola Pota"/>
+        <a:font script="Mong" typeface="Mongolian Baiti"/>
+        <a:font script="Viet" typeface="Times New Roman"/>
+        <a:font script="Uigh" typeface="Microsoft Uighur"/>
+        <a:font script="Geor" typeface="Sylfaen"/>
+        <a:font script="Armn" typeface="Arial"/>
+        <a:font script="Bugi" typeface="Leelawadee UI"/>
+        <a:font script="Bopo" typeface="Microsoft JhengHei"/>
+        <a:font script="Java" typeface="Javanese Text"/>
+        <a:font script="Lisu" typeface="Segoe UI"/>
+        <a:font script="Mymr" typeface="Myanmar Text"/>
+        <a:font script="Nkoo" typeface="Ebrima"/>
+        <a:font script="Olck" typeface="Nirmala UI"/>
+        <a:font script="Osma" typeface="Ebrima"/>
+        <a:font script="Phag" typeface="Phagspa"/>
+        <a:font script="Syrn" typeface="Estrangelo Edessa"/>
+        <a:font script="Syrj" typeface="Estrangelo Edessa"/>
+        <a:font script="Syre" typeface="Estrangelo Edessa"/>
+        <a:font script="Sora" typeface="Nirmala UI"/>
+        <a:font script="Tale" typeface="Microsoft Tai Le"/>
+        <a:font script="Talu" typeface="Microsoft New Tai Lue"/>
+        <a:font script="Tfng" typeface="Ebrima"/>
+      </a:majorFont>
+      <a:minorFont>
+        <a:latin typeface="Calibri" panose="020F0502020204030204"/>
+        <a:ea typeface=""/>
+        <a:cs typeface=""/>
+        <a:font script="Jpan" typeface="游ゴシック"/>
+        <a:font script="Hang" typeface="맑은 고딕"/>
+        <a:font script="Hans" typeface="等线"/>
+        <a:font script="Hant" typeface="新細明體"/>
+        <a:font script="Arab" typeface="Arial"/>
+        <a:font script="Hebr" typeface="Arial"/>
+        <a:font script="Thai" typeface="Cordia New"/>
+        <a:font script="Ethi" typeface="Nyala"/>
+        <a:font script="Beng" typeface="Vrinda"/>
+        <a:font script="Gujr" typeface="Shruti"/>
+        <a:font script="Khmr" typeface="DaunPenh"/>
+        <a:font script="Knda" typeface="Tunga"/>
+        <a:font script="Guru" typeface="Raavi"/>
+        <a:font script="Cans" typeface="Euphemia"/>
+        <a:font script="Cher" typeface="Plantagenet Cherokee"/>
+        <a:font script="Yiii" typeface="Microsoft Yi Baiti"/>
+        <a:font script="Tibt" typeface="Microsoft Himalaya"/>
+        <a:font script="Thaa" typeface="MV Boli"/>
+        <a:font script="Deva" typeface="Mangal"/>
+        <a:font script="Telu" typeface="Gautami"/>
+        <a:font script="Taml" typeface="Latha"/>
+        <a:font script="Syrc" typeface="Estrangelo Edessa"/>
+        <a:font script="Orya" typeface="Kalinga"/>
+        <a:font script="Mlym" typeface="Kartika"/>
+        <a:font script="Laoo" typeface="DokChampa"/>
+        <a:font script="Sinh" typeface="Iskoola Pota"/>
+        <a:font script="Mong" typeface="Mongolian Baiti"/>
+        <a:font script="Viet" typeface="Arial"/>
+        <a:font script="Uigh" typeface="Microsoft Uighur"/>
+        <a:font script="Geor" typeface="Sylfaen"/>
+        <a:font script="Armn" typeface="Arial"/>
+        <a:font script="Bugi" typeface="Leelawadee UI"/>
+        <a:font script="Bopo" typeface="Microsoft JhengHei"/>
+        <a:font script="Java" typeface="Javanese Text"/>
+        <a:font script="Lisu" typeface="Segoe UI"/>
+        <a:font script="Mymr" typeface="Myanmar Text"/>
+        <a:font script="Nkoo" typeface="Ebrima"/>
+        <a:font script="Olck" typeface="Nirmala UI"/>
+        <a:font script="Osma" typeface="Ebrima"/>
+        <a:font script="Phag" typeface="Phagspa"/>
+        <a:font script="Syrn" typeface="Estrangelo Edessa"/>
+        <a:font script="Syrj" typeface="Estrangelo Edessa"/>
+        <a:font script="Syre" typeface="Estrangelo Edessa"/>
+        <a:font script="Sora" typeface="Nirmala UI"/>
+        <a:font script="Tale" typeface="Microsoft Tai Le"/>
+        <a:font script="Talu" typeface="Microsoft New Tai Lue"/>
+        <a:font script="Tfng" typeface="Ebrima"/>
+      </a:minorFont>
+    </a:fontScheme>
+    <a:fmtScheme name="Office">
+      <a:fillStyleLst>
+        <a:solidFill>
+          <a:schemeClr val="phClr"/>
+        </a:solidFill>
+        <a:gradFill rotWithShape="1">
+          <a:gsLst>
+            <a:gs pos="0">
+              <a:schemeClr val="phClr">
+                <a:lumMod val="110000"/>
+                <a:satMod val="105000"/>
+                <a:tint val="67000"/>
+              </a:schemeClr>
+            </a:gs>
+            <a:gs pos="50000">
+              <a:schemeClr val="phClr">
+                <a:lumMod val="105000"/>
+                <a:satMod val="103000"/>
+                <a:tint val="73000"/>
+              </a:schemeClr>
+            </a:gs>
+            <a:gs pos="100000">
+              <a:schemeClr val="phClr">
+                <a:lumMod val="105000"/>
+                <a:satMod val="109000"/>
+                <a:tint val="81000"/>
+              </a:schemeClr>
+            </a:gs>
+          </a:gsLst>
+          <a:lin ang="5400000" scaled="0"/>
+        </a:gradFill>
+        <a:gradFill rotWithShape="1">
+          <a:gsLst>
+            <a:gs pos="0">
+              <a:schemeClr val="phClr">
+                <a:satMod val="103000"/>
+                <a:lumMod val="102000"/>
+                <a:tint val="94000"/>
+              </a:schemeClr>
+            </a:gs>
+            <a:gs pos="50000">
+              <a:schemeClr val="phClr">
+                <a:satMod val="110000"/>
+                <a:lumMod val="100000"/>
+                <a:shade val="100000"/>
+              </a:schemeClr>
+            </a:gs>
+            <a:gs pos="100000">
+              <a:schemeClr val="phClr">
+                <a:lumMod val="99000"/>
+                <a:satMod val="120000"/>
+                <a:shade val="78000"/>
+              </a:schemeClr>
+            </a:gs>
+          </a:gsLst>
+          <a:lin ang="5400000" scaled="0"/>
+        </a:gradFill>
+      </a:fillStyleLst>
+      <a:lnStyleLst>
+        <a:ln w="6350" cap="flat" cmpd="sng" algn="ctr">
+          <a:solidFill>
+            <a:schemeClr val="phClr"/>
+          </a:solidFill>
+          <a:prstDash val="solid"/>
+          <a:miter lim="800000"/>
+        </a:ln>
+        <a:ln w="12700" cap="flat" cmpd="sng" algn="ctr">
+          <a:solidFill>
+            <a:schemeClr val="phClr"/>
+          </a:solidFill>
+          <a:prstDash val="solid"/>
+          <a:miter lim="800000"/>
+        </a:ln>
+        <a:ln w="19050" cap="flat" cmpd="sng" algn="ctr">
+          <a:solidFill>
+            <a:schemeClr val="phClr"/>
+          </a:solidFill>
+          <a:prstDash val="solid"/>
+          <a:miter lim="800000"/>
+        </a:ln>
+      </a:lnStyleLst>
+      <a:effectStyleLst>
+        <a:effectStyle>
+          <a:effectLst/>
+        </a:effectStyle>
+        <a:effectStyle>
+          <a:effectLst/>
+        </a:effectStyle>
+        <a:effectStyle>
+          <a:effectLst>
+            <a:outerShdw blurRad="57150" dist="19050" dir="5400000" algn="ctr" rotWithShape="0">
+              <a:srgbClr val="000000">
+                <a:alpha val="63000"/>
+              </a:srgbClr>
+            </a:outerShdw>
+          </a:effectLst>
+        </a:effectStyle>
+      </a:effectStyleLst>
+      <a:bgFillStyleLst>
+        <a:solidFill>
+          <a:schemeClr val="phClr"/>
+        </a:solidFill>
+        <a:solidFill>
+          <a:schemeClr val="phClr">
+            <a:tint val="95000"/>
+            <a:satMod val="170000"/>
+          </a:schemeClr>
+        </a:solidFill>
+        <a:gradFill rotWithShape="1">
+          <a:gsLst>
+            <a:gs pos="0">
+              <a:schemeClr val="phClr">
+                <a:tint val="93000"/>
+                <a:satMod val="150000"/>
+                <a:shade val="98000"/>
+                <a:lumMod val="102000"/>
+              </a:schemeClr>
+            </a:gs>
+            <a:gs pos="50000">
+              <a:schemeClr val="phClr">
+                <a:tint val="98000"/>
+                <a:satMod val="130000"/>
+                <a:shade val="90000"/>
+                <a:lumMod val="103000"/>
+              </a:schemeClr>
+            </a:gs>
+            <a:gs pos="100000">
+              <a:schemeClr val="phClr">
+                <a:shade val="63000"/>
+                <a:satMod val="120000"/>
+              </a:schemeClr>
+            </a:gs>
+          </a:gsLst>
+          <a:lin ang="5400000" scaled="0"/>
+        </a:gradFill>
+      </a:bgFillStyleLst>
+    </a:fmtScheme>
+  </a:themeElements>
+  <a:objectDefaults/>
+  <a:extraClrSchemeLst/>
+  <a:extLst>
+    <a:ext uri="{05A4C25C-085E-4340-85A3-A5531E510DB2}">
+      <thm15:themeFamily xmlns:thm15="http://schemas.microsoft.com/office/thememl/2012/main" name="Office Theme" id="{62F939B6-93AF-4DB8-9C6B-D6C7DFDC589F}" vid="{4A3C46E8-61CC-4603-A589-7422A47A8E4A}"/>
+    </a:ext>
+  </a:extLst>
+</a:theme>
 </file>
</xml_diff>

<commit_message>
Aclarar la diapositiva del experimento en historia_unreal.pptx
La diapositiva 9 deja los porcentajes sin base y explica el estudio con
dos bloques: la nota sube un poco (de 5 a 5,4) y los relatos se parecen
más. Cifras exactas en las notas. Solo cambian la diapositiva 9 y sus
notas; el resto del archivo es idéntico byte a byte.

Co-Authored-By: Claude Opus 5.5 <noreply@anthropic.com>
</commit_message>
<xml_diff>
--- a/diapositivas/historia_unreal.pptx
+++ b/diapositivas/historia_unreal.pptx
@@ -1368,10 +1368,31 @@
           <a:lstStyle/>
           <a:p>
             <a:r>
-              <a:rPr lang="en-US" dirty="0"/>
-              <a:t>Estudio: Anil R. Doshi y Oliver P. Hauser, «Generative AI enhances individual creativity but reduces the collective diversity of novel content», Science Advances, 12 de julio de 2024. 293 escritores y 600 evaluadores.
-Cifras exactas: con cinco ideas de la IA, los relatos fueron un 8,1 % más novedosos y un 9,0 % más útiles que los escritos sin ayuda. Las mejoras fueron mayores en las personas menos creativas (hasta +10,7 % en novedad y +11,5 % en utilidad). Pero los relatos hechos con ayuda de la IA se parecían más entre sí: un 10,7 % del rango de similitud con una idea de la IA (8,9 % con cinco).
-Ojo: la IA no lo hizo peor. Ayudó a cada persona. El problema aparece al mirar el conjunto.</a:t>
+              <a:t>Cómo explicarlo: 293 personas escribieron un relato de unas ocho frases. Unas lo escribieron solas; otras recibieron una idea de una IA, o hasta cinco, para inspirarse. Luego 600 personas los puntuaron del 1 al 9 en originalidad y utilidad, sin saber quién había usado IA.</a:t>
+            </a:r>
+          </a:p>
+          <a:p/>
+          <a:p>
+            <a:r>
+              <a:t>Bloque izquierdo: con ideas de la IA, la nota media subió alrededor de un 8–9 %. Para hacerse una idea, es como pasar de un 5 a un 5,4. Una mejora pequeña, pero real. A quien más ayudó fue a los menos creativos.</a:t>
+            </a:r>
+          </a:p>
+          <a:p/>
+          <a:p>
+            <a:r>
+              <a:t>Bloque derecho: un ordenador midió cuánto se parecían los relatos entre sí. Los hechos con ideas de la IA se parecían bastante más: todos tiraban hacia las mismas ideas, como si cada uno hubiera copiado un poco del mismo compañero.</a:t>
+            </a:r>
+          </a:p>
+          <a:p/>
+          <a:p>
+            <a:r>
+              <a:t>Cifras exactas por si alguien pregunta: con cinco ideas de la IA, +8,1 % en originalidad y +9,0 % en utilidad respecto a quienes escribieron solos (en los menos creativos, +10,7 % y +11,5 %). El aumento del parecido entre relatos equivale al 10,7 % del rango de variación de los relatos escritos sin IA (con una idea; 8,9 % con cinco). No es «un 11 % más parecidos»: es una medida técnica, por eso no se pone en la diapositiva.</a:t>
+            </a:r>
+          </a:p>
+          <a:p/>
+          <a:p>
+            <a:r>
+              <a:t>Ojo: la IA no lo hizo peor. Ayudó a cada persona. El problema aparece al mirar el conjunto.</a:t>
             </a:r>
           </a:p>
         </p:txBody>
@@ -8771,7 +8792,7 @@
                   <a:schemeClr val="tx1"/>
                 </a:solidFill>
               </a:rPr>
-              <a:t>Escribieron un relato corto: unos solos y otros con ideas de una IA. Después, 600 personas valoraron los relatos sin saber quién había usado IA.</a:t>
+              <a:t>Escribieron un relato muy corto: unos solos y otros con ideas de una IA. Después, 600 personas les pusieron nota del 1 al 9, sin saber quién había usado IA.</a:t>
             </a:r>
             <a:endParaRPr lang="en-US" sz="1800" dirty="0"/>
           </a:p>
@@ -8786,7 +8807,7 @@
         <p:spPr>
           <a:xfrm>
             <a:off x="548640" y="2468880"/>
-            <a:ext cx="3454298" cy="2651760"/>
+            <a:ext cx="5364327" cy="2651760"/>
           </a:xfrm>
           <a:prstGeom prst="roundRect">
             <a:avLst>
@@ -8807,8 +8828,8 @@
         </p:nvSpPr>
         <p:spPr>
           <a:xfrm>
-            <a:off x="822960" y="2651760"/>
-            <a:ext cx="2905658" cy="1188720"/>
+            <a:off x="822959" y="2606040"/>
+            <a:ext cx="4815687" cy="1097280"/>
           </a:xfrm>
           <a:prstGeom prst="rect">
             <a:avLst/>
@@ -8829,7 +8850,7 @@
                   <a:schemeClr val="accent2"/>
                 </a:solidFill>
               </a:rPr>
-              <a:t>+8 %</a:t>
+              <a:t>5  →  5,4</a:t>
             </a:r>
             <a:endParaRPr lang="en-US" sz="6000" dirty="0"/>
           </a:p>
@@ -8843,8 +8864,8 @@
         </p:nvSpPr>
         <p:spPr>
           <a:xfrm>
-            <a:off x="822960" y="3886200"/>
-            <a:ext cx="2905658" cy="1051560"/>
+            <a:off x="822959" y="3749039"/>
+            <a:ext cx="4815687" cy="1280160"/>
           </a:xfrm>
           <a:prstGeom prst="rect">
             <a:avLst/>
@@ -8865,7 +8886,7 @@
                   <a:schemeClr val="tx1"/>
                 </a:solidFill>
               </a:rPr>
-              <a:t>más originales</a:t>
+              <a:t>Cada relato, un poco mejor</a:t>
             </a:r>
             <a:endParaRPr lang="en-US" sz="2000" dirty="0"/>
           </a:p>
@@ -8879,7 +8900,7 @@
                   <a:schemeClr val="tx2"/>
                 </a:solidFill>
               </a:rPr>
-              <a:t>con ideas de la IA</a:t>
+              <a:t>Con ideas de la IA, la nota sube un poco: si sin IA sacaban un 5, con IA sacaban un 5,4.</a:t>
             </a:r>
             <a:endParaRPr lang="en-US" sz="2000" dirty="0"/>
           </a:p>
@@ -8887,14 +8908,14 @@
       </p:sp>
       <p:sp>
         <p:nvSpPr>
-          <p:cNvPr id="9" name="Tarjeta"/>
+          <p:cNvPr id="12" name="Tarjeta"/>
           <p:cNvSpPr/>
           <p:nvPr/>
         </p:nvSpPr>
         <p:spPr>
           <a:xfrm>
-            <a:off x="4368698" y="2468880"/>
-            <a:ext cx="3454298" cy="2651760"/>
+            <a:off x="6278727" y="2468880"/>
+            <a:ext cx="5364327" cy="2651760"/>
           </a:xfrm>
           <a:prstGeom prst="roundRect">
             <a:avLst>
@@ -8909,14 +8930,14 @@
       </p:sp>
       <p:sp>
         <p:nvSpPr>
-          <p:cNvPr id="10" name="Text 7"/>
+          <p:cNvPr id="13" name="Text 10"/>
           <p:cNvSpPr txBox="1"/>
           <p:nvPr/>
         </p:nvSpPr>
         <p:spPr>
           <a:xfrm>
-            <a:off x="4643018" y="2651760"/>
-            <a:ext cx="2905658" cy="1188720"/>
+            <a:off x="6553047" y="2606040"/>
+            <a:ext cx="4815687" cy="1097280"/>
           </a:xfrm>
           <a:prstGeom prst="rect">
             <a:avLst/>
@@ -8932,12 +8953,12 @@
               <a:buNone/>
             </a:pPr>
             <a:r>
-              <a:rPr lang="en-US" sz="6000" b="1" dirty="0">
-                <a:solidFill>
-                  <a:schemeClr val="accent2"/>
+              <a:rPr lang="en-US" sz="4800" b="1" dirty="0">
+                <a:solidFill>
+                  <a:schemeClr val="accent3"/>
                 </a:solidFill>
               </a:rPr>
-              <a:t>+9 %</a:t>
+              <a:t>Más parecidos</a:t>
             </a:r>
             <a:endParaRPr lang="en-US" sz="6000" dirty="0"/>
           </a:p>
@@ -8945,14 +8966,14 @@
       </p:sp>
       <p:sp>
         <p:nvSpPr>
-          <p:cNvPr id="11" name="Text 8"/>
+          <p:cNvPr id="14" name="Text 11"/>
           <p:cNvSpPr txBox="1"/>
           <p:nvPr/>
         </p:nvSpPr>
         <p:spPr>
           <a:xfrm>
-            <a:off x="4643018" y="3886200"/>
-            <a:ext cx="2905658" cy="1051560"/>
+            <a:off x="6553047" y="3749039"/>
+            <a:ext cx="4815687" cy="1280160"/>
           </a:xfrm>
           <a:prstGeom prst="rect">
             <a:avLst/>
@@ -8973,7 +8994,7 @@
                   <a:schemeClr val="tx1"/>
                 </a:solidFill>
               </a:rPr>
-              <a:t>más útiles</a:t>
+              <a:t>Todos los relatos, más iguales</a:t>
             </a:r>
             <a:endParaRPr lang="en-US" sz="2000" dirty="0"/>
           </a:p>
@@ -8987,7 +9008,7 @@
                   <a:schemeClr val="tx2"/>
                 </a:solidFill>
               </a:rPr>
-              <a:t>con ideas de la IA</a:t>
+              <a:t>Un ordenador comparó los textos: los hechos con IA tiraban hacia las mismas ideas.</a:t>
             </a:r>
             <a:endParaRPr lang="en-US" sz="2000" dirty="0"/>
           </a:p>
@@ -8995,36 +9016,14 @@
       </p:sp>
       <p:sp>
         <p:nvSpPr>
-          <p:cNvPr id="12" name="Tarjeta"/>
-          <p:cNvSpPr/>
-          <p:nvPr/>
-        </p:nvSpPr>
-        <p:spPr>
-          <a:xfrm>
-            <a:off x="8188757" y="2468880"/>
-            <a:ext cx="3454298" cy="2651760"/>
-          </a:xfrm>
-          <a:prstGeom prst="roundRect">
-            <a:avLst>
-              <a:gd name="adj" fmla="val 5172"/>
-            </a:avLst>
-          </a:prstGeom>
-          <a:solidFill>
-            <a:schemeClr val="bg2"/>
-          </a:solidFill>
-          <a:ln/>
-        </p:spPr>
-      </p:sp>
-      <p:sp>
-        <p:nvSpPr>
-          <p:cNvPr id="13" name="Text 10"/>
+          <p:cNvPr id="15" name="Text 12"/>
           <p:cNvSpPr txBox="1"/>
           <p:nvPr/>
         </p:nvSpPr>
         <p:spPr>
           <a:xfrm>
-            <a:off x="8463077" y="2651760"/>
-            <a:ext cx="2905658" cy="1188720"/>
+            <a:off x="548640" y="5394960"/>
+            <a:ext cx="11094415" cy="365760"/>
           </a:xfrm>
           <a:prstGeom prst="rect">
             <a:avLst/>
@@ -9036,102 +9035,16 @@
           <a:bodyPr wrap="square" lIns="0" tIns="0" rIns="0" bIns="0" rtlCol="0" anchor="ctr"/>
           <a:lstStyle/>
           <a:p>
-            <a:pPr marL="0" indent="0" algn="ctr">
+            <a:pPr marL="0" indent="0">
               <a:buNone/>
             </a:pPr>
             <a:r>
-              <a:rPr lang="en-US" sz="6000" b="1" dirty="0">
-                <a:solidFill>
-                  <a:schemeClr val="accent3"/>
+              <a:rPr lang="en-US" sz="1300" i="1" dirty="0">
+                <a:solidFill>
+                  <a:schemeClr val="accent5"/>
                 </a:solidFill>
               </a:rPr>
-              <a:t>+11 %</a:t>
-            </a:r>
-            <a:endParaRPr lang="en-US" sz="6000" dirty="0"/>
-          </a:p>
-        </p:txBody>
-      </p:sp>
-      <p:sp>
-        <p:nvSpPr>
-          <p:cNvPr id="14" name="Text 11"/>
-          <p:cNvSpPr txBox="1"/>
-          <p:nvPr/>
-        </p:nvSpPr>
-        <p:spPr>
-          <a:xfrm>
-            <a:off x="8463077" y="3886200"/>
-            <a:ext cx="2905658" cy="1051560"/>
-          </a:xfrm>
-          <a:prstGeom prst="rect">
-            <a:avLst/>
-          </a:prstGeom>
-          <a:noFill/>
-          <a:ln/>
-        </p:spPr>
-        <p:txBody>
-          <a:bodyPr wrap="square" lIns="0" tIns="0" rIns="0" bIns="0" rtlCol="0" anchor="t"/>
-          <a:lstStyle/>
-          <a:p>
-            <a:pPr marL="0" indent="0" algn="ctr">
-              <a:buNone/>
-            </a:pPr>
-            <a:r>
-              <a:rPr lang="en-US" sz="2000" b="1" dirty="0">
-                <a:solidFill>
-                  <a:schemeClr val="tx1"/>
-                </a:solidFill>
-              </a:rPr>
-              <a:t>más parecidos entre sí</a:t>
-            </a:r>
-            <a:endParaRPr lang="en-US" sz="2000" dirty="0"/>
-          </a:p>
-          <a:p>
-            <a:pPr marL="0" indent="0" algn="ctr">
-              <a:buNone/>
-            </a:pPr>
-            <a:r>
-              <a:rPr lang="en-US" sz="1500" dirty="0">
-                <a:solidFill>
-                  <a:schemeClr val="tx2"/>
-                </a:solidFill>
-              </a:rPr>
-              <a:t>los relatos hechos con IA</a:t>
-            </a:r>
-            <a:endParaRPr lang="en-US" sz="2000" dirty="0"/>
-          </a:p>
-        </p:txBody>
-      </p:sp>
-      <p:sp>
-        <p:nvSpPr>
-          <p:cNvPr id="15" name="Text 12"/>
-          <p:cNvSpPr txBox="1"/>
-          <p:nvPr/>
-        </p:nvSpPr>
-        <p:spPr>
-          <a:xfrm>
-            <a:off x="548640" y="5394960"/>
-            <a:ext cx="11094415" cy="365760"/>
-          </a:xfrm>
-          <a:prstGeom prst="rect">
-            <a:avLst/>
-          </a:prstGeom>
-          <a:noFill/>
-          <a:ln/>
-        </p:spPr>
-        <p:txBody>
-          <a:bodyPr wrap="square" lIns="0" tIns="0" rIns="0" bIns="0" rtlCol="0" anchor="ctr"/>
-          <a:lstStyle/>
-          <a:p>
-            <a:pPr marL="0" indent="0">
-              <a:buNone/>
-            </a:pPr>
-            <a:r>
-              <a:rPr lang="en-US" sz="1300" i="1" dirty="0">
-                <a:solidFill>
-                  <a:schemeClr val="accent5"/>
-                </a:solidFill>
-              </a:rPr>
-              <a:t>Doshi y Hauser (2024), Science Advances</a:t>
+              <a:t>Doshi y Hauser (2024), Science Advances. A quien más ayudó la IA fue a las personas menos creativas.</a:t>
             </a:r>
             <a:endParaRPr lang="en-US" sz="1300" dirty="0"/>
           </a:p>

</xml_diff>

<commit_message>
Fijar Curso.pptx como presentación de referencia
Co-Authored-By: Claude Opus 5.5 <noreply@anthropic.com>
</commit_message>
<xml_diff>
--- a/diapositivas/historia_unreal.pptx
+++ b/diapositivas/historia_unreal.pptx
@@ -1823,7 +1823,7 @@
           </a:prstGeom>
           <a:extLst>
             <a:ext uri="{C572A759-6A51-4108-AA02-DFA0A04FC94B}">
-              <ma14:wrappingTextBoxFlag xmlns="" xmlns:ma14="http://schemas.microsoft.com/office/mac/drawingml/2011/main" val="0"/>
+              <ma14:wrappingTextBoxFlag xmlns:ma14="http://schemas.microsoft.com/office/mac/drawingml/2011/main" xmlns="" val="0"/>
             </a:ext>
           </a:extLst>
         </p:spPr>
@@ -1978,7 +1978,7 @@
           </a:prstGeom>
           <a:extLst>
             <a:ext uri="{C572A759-6A51-4108-AA02-DFA0A04FC94B}">
-              <ma14:wrappingTextBoxFlag xmlns="" xmlns:ma14="http://schemas.microsoft.com/office/mac/drawingml/2011/main" val="0"/>
+              <ma14:wrappingTextBoxFlag xmlns:ma14="http://schemas.microsoft.com/office/mac/drawingml/2011/main" xmlns="" val="0"/>
             </a:ext>
           </a:extLst>
         </p:spPr>
@@ -2053,7 +2053,7 @@
           </a:prstGeom>
           <a:extLst>
             <a:ext uri="{C572A759-6A51-4108-AA02-DFA0A04FC94B}">
-              <ma14:wrappingTextBoxFlag xmlns="" xmlns:ma14="http://schemas.microsoft.com/office/mac/drawingml/2011/main" val="0"/>
+              <ma14:wrappingTextBoxFlag xmlns:ma14="http://schemas.microsoft.com/office/mac/drawingml/2011/main" xmlns="" val="0"/>
             </a:ext>
           </a:extLst>
         </p:spPr>
@@ -2449,7 +2449,23 @@
                   <a:schemeClr val="accent1"/>
                 </a:solidFill>
               </a:rPr>
-              <a:t> relators </a:t>
+              <a:t> </a:t>
+            </a:r>
+            <a:r>
+              <a:rPr lang="en-US" sz="2000" dirty="0" err="1">
+                <a:solidFill>
+                  <a:schemeClr val="accent1"/>
+                </a:solidFill>
+              </a:rPr>
+              <a:t>relatos</a:t>
+            </a:r>
+            <a:r>
+              <a:rPr lang="en-US" sz="2000" dirty="0">
+                <a:solidFill>
+                  <a:schemeClr val="accent1"/>
+                </a:solidFill>
+              </a:rPr>
+              <a:t> </a:t>
             </a:r>
             <a:r>
               <a:rPr lang="en-US" sz="2000" dirty="0" err="1">
@@ -2962,7 +2978,7 @@
           </a:prstGeom>
           <a:extLst>
             <a:ext uri="{C572A759-6A51-4108-AA02-DFA0A04FC94B}">
-              <ma14:wrappingTextBoxFlag xmlns="" xmlns:ma14="http://schemas.microsoft.com/office/mac/drawingml/2011/main" val="0"/>
+              <ma14:wrappingTextBoxFlag xmlns:ma14="http://schemas.microsoft.com/office/mac/drawingml/2011/main" xmlns="" val="0"/>
             </a:ext>
           </a:extLst>
         </p:spPr>
@@ -4027,7 +4043,7 @@
           </a:prstGeom>
           <a:extLst>
             <a:ext uri="{C572A759-6A51-4108-AA02-DFA0A04FC94B}">
-              <ma14:wrappingTextBoxFlag xmlns="" xmlns:ma14="http://schemas.microsoft.com/office/mac/drawingml/2011/main" val="0"/>
+              <ma14:wrappingTextBoxFlag xmlns:ma14="http://schemas.microsoft.com/office/mac/drawingml/2011/main" xmlns="" val="0"/>
             </a:ext>
           </a:extLst>
         </p:spPr>
@@ -4187,7 +4203,7 @@
           </a:prstGeom>
           <a:extLst>
             <a:ext uri="{C572A759-6A51-4108-AA02-DFA0A04FC94B}">
-              <ma14:wrappingTextBoxFlag xmlns="" xmlns:ma14="http://schemas.microsoft.com/office/mac/drawingml/2011/main" val="0"/>
+              <ma14:wrappingTextBoxFlag xmlns:ma14="http://schemas.microsoft.com/office/mac/drawingml/2011/main" xmlns="" val="0"/>
             </a:ext>
           </a:extLst>
         </p:spPr>
@@ -4553,7 +4569,7 @@
           </a:prstGeom>
           <a:extLst>
             <a:ext uri="{C572A759-6A51-4108-AA02-DFA0A04FC94B}">
-              <ma14:wrappingTextBoxFlag xmlns="" xmlns:ma14="http://schemas.microsoft.com/office/mac/drawingml/2011/main" val="0"/>
+              <ma14:wrappingTextBoxFlag xmlns:ma14="http://schemas.microsoft.com/office/mac/drawingml/2011/main" xmlns="" val="0"/>
             </a:ext>
           </a:extLst>
         </p:spPr>
@@ -4677,7 +4693,7 @@
           </a:prstGeom>
           <a:extLst>
             <a:ext uri="{C572A759-6A51-4108-AA02-DFA0A04FC94B}">
-              <ma14:wrappingTextBoxFlag xmlns="" xmlns:ma14="http://schemas.microsoft.com/office/mac/drawingml/2011/main" val="0"/>
+              <ma14:wrappingTextBoxFlag xmlns:ma14="http://schemas.microsoft.com/office/mac/drawingml/2011/main" xmlns="" val="0"/>
             </a:ext>
           </a:extLst>
         </p:spPr>
@@ -5540,7 +5556,7 @@
           </a:prstGeom>
           <a:extLst>
             <a:ext uri="{C572A759-6A51-4108-AA02-DFA0A04FC94B}">
-              <ma14:wrappingTextBoxFlag xmlns="" xmlns:ma14="http://schemas.microsoft.com/office/mac/drawingml/2011/main" val="0"/>
+              <ma14:wrappingTextBoxFlag xmlns:ma14="http://schemas.microsoft.com/office/mac/drawingml/2011/main" xmlns="" val="0"/>
             </a:ext>
           </a:extLst>
         </p:spPr>
@@ -5959,7 +5975,7 @@
           </a:prstGeom>
           <a:extLst>
             <a:ext uri="{C572A759-6A51-4108-AA02-DFA0A04FC94B}">
-              <ma14:wrappingTextBoxFlag xmlns="" xmlns:ma14="http://schemas.microsoft.com/office/mac/drawingml/2011/main" val="0"/>
+              <ma14:wrappingTextBoxFlag xmlns:ma14="http://schemas.microsoft.com/office/mac/drawingml/2011/main" xmlns="" val="0"/>
             </a:ext>
           </a:extLst>
         </p:spPr>
@@ -6844,7 +6860,7 @@
           </a:prstGeom>
           <a:extLst>
             <a:ext uri="{C572A759-6A51-4108-AA02-DFA0A04FC94B}">
-              <ma14:wrappingTextBoxFlag xmlns="" xmlns:ma14="http://schemas.microsoft.com/office/mac/drawingml/2011/main" val="0"/>
+              <ma14:wrappingTextBoxFlag xmlns:ma14="http://schemas.microsoft.com/office/mac/drawingml/2011/main" xmlns="" val="0"/>
             </a:ext>
           </a:extLst>
         </p:spPr>
@@ -7536,7 +7552,7 @@
           </a:prstGeom>
           <a:extLst>
             <a:ext uri="{C572A759-6A51-4108-AA02-DFA0A04FC94B}">
-              <ma14:wrappingTextBoxFlag xmlns="" xmlns:ma14="http://schemas.microsoft.com/office/mac/drawingml/2011/main" val="0"/>
+              <ma14:wrappingTextBoxFlag xmlns:ma14="http://schemas.microsoft.com/office/mac/drawingml/2011/main" xmlns="" val="0"/>
             </a:ext>
           </a:extLst>
         </p:spPr>
@@ -8529,7 +8545,7 @@
           </a:prstGeom>
           <a:extLst>
             <a:ext uri="{C572A759-6A51-4108-AA02-DFA0A04FC94B}">
-              <ma14:wrappingTextBoxFlag xmlns="" xmlns:ma14="http://schemas.microsoft.com/office/mac/drawingml/2011/main" val="0"/>
+              <ma14:wrappingTextBoxFlag xmlns:ma14="http://schemas.microsoft.com/office/mac/drawingml/2011/main" xmlns="" val="0"/>
             </a:ext>
           </a:extLst>
         </p:spPr>
@@ -8684,7 +8700,7 @@
           </a:prstGeom>
           <a:extLst>
             <a:ext uri="{C572A759-6A51-4108-AA02-DFA0A04FC94B}">
-              <ma14:wrappingTextBoxFlag xmlns="" xmlns:ma14="http://schemas.microsoft.com/office/mac/drawingml/2011/main" val="0"/>
+              <ma14:wrappingTextBoxFlag xmlns:ma14="http://schemas.microsoft.com/office/mac/drawingml/2011/main" xmlns="" val="0"/>
             </a:ext>
           </a:extLst>
         </p:spPr>
@@ -9126,7 +9142,7 @@
           </a:prstGeom>
           <a:extLst>
             <a:ext uri="{C572A759-6A51-4108-AA02-DFA0A04FC94B}">
-              <ma14:wrappingTextBoxFlag xmlns="" xmlns:ma14="http://schemas.microsoft.com/office/mac/drawingml/2011/main" val="0"/>
+              <ma14:wrappingTextBoxFlag xmlns:ma14="http://schemas.microsoft.com/office/mac/drawingml/2011/main" xmlns="" val="0"/>
             </a:ext>
           </a:extLst>
         </p:spPr>

</xml_diff>